<commit_message>
Update capstone documents and small print fix
Replace/update presentation and report files (Capstone_Presentation.pptx, Capstone_Report.docx, Findings.docx) and add a PDF export (Capstone_Report.pdf). Also adjust preprocessing.py log message to remove the explicit “(Step 4)” marker for a more generic completion message.
</commit_message>
<xml_diff>
--- a/Capstone_Presentation.pptx
+++ b/Capstone_Presentation.pptx
@@ -322,7 +322,7 @@
           <a:p>
             <a:fld id="{5BCAD085-E8A6-8845-BD4E-CB4CCA059FC4}" type="datetimeFigureOut">
               <a:rPr lang="en-US" smtClean="0"/>
-              <a:t>5/8/2026</a:t>
+              <a:t>5/17/2026</a:t>
             </a:fld>
             <a:endParaRPr lang="en-US"/>
           </a:p>
@@ -490,7 +490,7 @@
           <a:p>
             <a:fld id="{5BCAD085-E8A6-8845-BD4E-CB4CCA059FC4}" type="datetimeFigureOut">
               <a:rPr lang="en-US" smtClean="0"/>
-              <a:t>5/8/2026</a:t>
+              <a:t>5/17/2026</a:t>
             </a:fld>
             <a:endParaRPr lang="en-US"/>
           </a:p>
@@ -668,7 +668,7 @@
           <a:p>
             <a:fld id="{5BCAD085-E8A6-8845-BD4E-CB4CCA059FC4}" type="datetimeFigureOut">
               <a:rPr lang="en-US" smtClean="0"/>
-              <a:t>5/8/2026</a:t>
+              <a:t>5/17/2026</a:t>
             </a:fld>
             <a:endParaRPr lang="en-US"/>
           </a:p>
@@ -836,7 +836,7 @@
           <a:p>
             <a:fld id="{5BCAD085-E8A6-8845-BD4E-CB4CCA059FC4}" type="datetimeFigureOut">
               <a:rPr lang="en-US" smtClean="0"/>
-              <a:t>5/8/2026</a:t>
+              <a:t>5/17/2026</a:t>
             </a:fld>
             <a:endParaRPr lang="en-US"/>
           </a:p>
@@ -1081,7 +1081,7 @@
           <a:p>
             <a:fld id="{5BCAD085-E8A6-8845-BD4E-CB4CCA059FC4}" type="datetimeFigureOut">
               <a:rPr lang="en-US" smtClean="0"/>
-              <a:t>5/8/2026</a:t>
+              <a:t>5/17/2026</a:t>
             </a:fld>
             <a:endParaRPr lang="en-US"/>
           </a:p>
@@ -1366,7 +1366,7 @@
           <a:p>
             <a:fld id="{5BCAD085-E8A6-8845-BD4E-CB4CCA059FC4}" type="datetimeFigureOut">
               <a:rPr lang="en-US" smtClean="0"/>
-              <a:t>5/8/2026</a:t>
+              <a:t>5/17/2026</a:t>
             </a:fld>
             <a:endParaRPr lang="en-US"/>
           </a:p>
@@ -1785,7 +1785,7 @@
           <a:p>
             <a:fld id="{5BCAD085-E8A6-8845-BD4E-CB4CCA059FC4}" type="datetimeFigureOut">
               <a:rPr lang="en-US" smtClean="0"/>
-              <a:t>5/8/2026</a:t>
+              <a:t>5/17/2026</a:t>
             </a:fld>
             <a:endParaRPr lang="en-US"/>
           </a:p>
@@ -1902,7 +1902,7 @@
           <a:p>
             <a:fld id="{5BCAD085-E8A6-8845-BD4E-CB4CCA059FC4}" type="datetimeFigureOut">
               <a:rPr lang="en-US" smtClean="0"/>
-              <a:t>5/8/2026</a:t>
+              <a:t>5/17/2026</a:t>
             </a:fld>
             <a:endParaRPr lang="en-US"/>
           </a:p>
@@ -1997,7 +1997,7 @@
           <a:p>
             <a:fld id="{5BCAD085-E8A6-8845-BD4E-CB4CCA059FC4}" type="datetimeFigureOut">
               <a:rPr lang="en-US" smtClean="0"/>
-              <a:t>5/8/2026</a:t>
+              <a:t>5/17/2026</a:t>
             </a:fld>
             <a:endParaRPr lang="en-US"/>
           </a:p>
@@ -2272,7 +2272,7 @@
           <a:p>
             <a:fld id="{5BCAD085-E8A6-8845-BD4E-CB4CCA059FC4}" type="datetimeFigureOut">
               <a:rPr lang="en-US" smtClean="0"/>
-              <a:t>5/8/2026</a:t>
+              <a:t>5/17/2026</a:t>
             </a:fld>
             <a:endParaRPr lang="en-US"/>
           </a:p>
@@ -2524,7 +2524,7 @@
           <a:p>
             <a:fld id="{5BCAD085-E8A6-8845-BD4E-CB4CCA059FC4}" type="datetimeFigureOut">
               <a:rPr lang="en-US" smtClean="0"/>
-              <a:t>5/8/2026</a:t>
+              <a:t>5/17/2026</a:t>
             </a:fld>
             <a:endParaRPr lang="en-US"/>
           </a:p>
@@ -2735,7 +2735,7 @@
           <a:p>
             <a:fld id="{5BCAD085-E8A6-8845-BD4E-CB4CCA059FC4}" type="datetimeFigureOut">
               <a:rPr lang="en-US" smtClean="0"/>
-              <a:t>5/8/2026</a:t>
+              <a:t>5/17/2026</a:t>
             </a:fld>
             <a:endParaRPr lang="en-US"/>
           </a:p>
@@ -3289,8 +3289,8 @@
         </p:nvSpPr>
         <p:spPr>
           <a:xfrm>
-            <a:off x="457200" y="2926080"/>
-            <a:ext cx="11247120" cy="1097280"/>
+            <a:off x="457200" y="3243887"/>
+            <a:ext cx="11247120" cy="461665"/>
           </a:xfrm>
           <a:prstGeom prst="rect">
             <a:avLst/>
@@ -3305,13 +3305,13 @@
           <a:p>
             <a:pPr algn="ctr"/>
             <a:r>
-              <a:rPr sz="2400" b="1" i="0">
+              <a:rPr sz="2400" b="1" i="0" dirty="0">
                 <a:solidFill>
                   <a:srgbClr val="FFFFFF"/>
                 </a:solidFill>
                 <a:latin typeface="Calibri"/>
               </a:rPr>
-              <a:t>A k-Nearest Neighbors Classifier Built From Scratch</a:t>
+              <a:t>A k-Nearest Neighbors Classifier</a:t>
             </a:r>
           </a:p>
         </p:txBody>
@@ -3858,7 +3858,7 @@
           <a:p>
             <a:pPr algn="l"/>
             <a:r>
-              <a:rPr sz="1600" b="1" i="0">
+              <a:rPr sz="1600" b="1" i="0" dirty="0">
                 <a:solidFill>
                   <a:srgbClr val="DD8452"/>
                 </a:solidFill>
@@ -3877,7 +3877,7 @@
         </p:nvSpPr>
         <p:spPr>
           <a:xfrm>
-            <a:off x="7726679" y="5212080"/>
+            <a:off x="7772400" y="4983480"/>
             <a:ext cx="3931920" cy="1371600"/>
           </a:xfrm>
           <a:prstGeom prst="rect">
@@ -3900,7 +3900,7 @@
               </a:spcAft>
             </a:pPr>
             <a:r>
-              <a:rPr sz="1300">
+              <a:rPr sz="1300" dirty="0">
                 <a:solidFill>
                   <a:srgbClr val="1A1A1A"/>
                 </a:solidFill>
@@ -3919,7 +3919,7 @@
               </a:spcAft>
             </a:pPr>
             <a:r>
-              <a:rPr sz="1300">
+              <a:rPr sz="1300" dirty="0">
                 <a:solidFill>
                   <a:srgbClr val="1A1A1A"/>
                 </a:solidFill>
@@ -3939,7 +3939,7 @@
         <p:spPr>
           <a:xfrm>
             <a:off x="457200" y="6492240"/>
-            <a:ext cx="7315200" cy="274320"/>
+            <a:ext cx="7315200" cy="246221"/>
           </a:xfrm>
           <a:prstGeom prst="rect">
             <a:avLst/>
@@ -3954,14 +3954,29 @@
           <a:p>
             <a:pPr algn="l"/>
             <a:r>
-              <a:rPr sz="1000" b="0" i="0">
+              <a:rPr sz="1000" b="0" i="0" dirty="0">
                 <a:solidFill>
                   <a:srgbClr val="556070"/>
                 </a:solidFill>
                 <a:latin typeface="Calibri"/>
               </a:rPr>
-              <a:t>Online Shoppers Purchase-Intention Capstone  |  kNN from Scratch</a:t>
-            </a:r>
+              <a:t>Online Shoppers Purchase-Intention Capstone  |  </a:t>
+            </a:r>
+            <a:r>
+              <a:rPr sz="1000" b="0" i="0" dirty="0" err="1">
+                <a:solidFill>
+                  <a:srgbClr val="556070"/>
+                </a:solidFill>
+                <a:latin typeface="Calibri"/>
+              </a:rPr>
+              <a:t>kNN</a:t>
+            </a:r>
+            <a:endParaRPr sz="1000" b="0" i="0" dirty="0">
+              <a:solidFill>
+                <a:srgbClr val="556070"/>
+              </a:solidFill>
+              <a:latin typeface="Calibri"/>
+            </a:endParaRPr>
           </a:p>
         </p:txBody>
       </p:sp>
@@ -5051,7 +5066,7 @@
         <p:spPr>
           <a:xfrm>
             <a:off x="457200" y="6492240"/>
-            <a:ext cx="7315200" cy="274320"/>
+            <a:ext cx="7315200" cy="246221"/>
           </a:xfrm>
           <a:prstGeom prst="rect">
             <a:avLst/>
@@ -5066,14 +5081,29 @@
           <a:p>
             <a:pPr algn="l"/>
             <a:r>
-              <a:rPr sz="1000" b="0" i="0">
+              <a:rPr sz="1000" b="0" i="0" dirty="0">
                 <a:solidFill>
                   <a:srgbClr val="556070"/>
                 </a:solidFill>
                 <a:latin typeface="Calibri"/>
               </a:rPr>
-              <a:t>Online Shoppers Purchase-Intention Capstone  |  kNN from Scratch</a:t>
-            </a:r>
+              <a:t>Online Shoppers Purchase-Intention Capstone  |  </a:t>
+            </a:r>
+            <a:r>
+              <a:rPr sz="1000" b="0" i="0" dirty="0" err="1">
+                <a:solidFill>
+                  <a:srgbClr val="556070"/>
+                </a:solidFill>
+                <a:latin typeface="Calibri"/>
+              </a:rPr>
+              <a:t>kNN</a:t>
+            </a:r>
+            <a:endParaRPr sz="1000" b="0" i="0" dirty="0">
+              <a:solidFill>
+                <a:srgbClr val="556070"/>
+              </a:solidFill>
+              <a:latin typeface="Calibri"/>
+            </a:endParaRPr>
           </a:p>
         </p:txBody>
       </p:sp>
@@ -6615,7 +6645,7 @@
         <p:spPr>
           <a:xfrm>
             <a:off x="457200" y="6492240"/>
-            <a:ext cx="7315200" cy="274320"/>
+            <a:ext cx="7315200" cy="246221"/>
           </a:xfrm>
           <a:prstGeom prst="rect">
             <a:avLst/>
@@ -6630,14 +6660,29 @@
           <a:p>
             <a:pPr algn="l"/>
             <a:r>
-              <a:rPr sz="1000" b="0" i="0">
+              <a:rPr sz="1000" b="0" i="0" dirty="0">
                 <a:solidFill>
                   <a:srgbClr val="556070"/>
                 </a:solidFill>
                 <a:latin typeface="Calibri"/>
               </a:rPr>
-              <a:t>Online Shoppers Purchase-Intention Capstone  |  kNN from Scratch</a:t>
-            </a:r>
+              <a:t>Online Shoppers Purchase-Intention Capstone  |  </a:t>
+            </a:r>
+            <a:r>
+              <a:rPr sz="1000" b="0" i="0" dirty="0" err="1">
+                <a:solidFill>
+                  <a:srgbClr val="556070"/>
+                </a:solidFill>
+                <a:latin typeface="Calibri"/>
+              </a:rPr>
+              <a:t>kNN</a:t>
+            </a:r>
+            <a:endParaRPr sz="1000" b="0" i="0" dirty="0">
+              <a:solidFill>
+                <a:srgbClr val="556070"/>
+              </a:solidFill>
+              <a:latin typeface="Calibri"/>
+            </a:endParaRPr>
           </a:p>
         </p:txBody>
       </p:sp>
@@ -7248,7 +7293,7 @@
         <p:spPr>
           <a:xfrm>
             <a:off x="457200" y="6492240"/>
-            <a:ext cx="7315200" cy="274320"/>
+            <a:ext cx="7315200" cy="246221"/>
           </a:xfrm>
           <a:prstGeom prst="rect">
             <a:avLst/>
@@ -7263,14 +7308,38 @@
           <a:p>
             <a:pPr algn="l"/>
             <a:r>
-              <a:rPr sz="1000" b="0" i="0">
+              <a:rPr sz="1000" b="0" i="0" dirty="0">
                 <a:solidFill>
                   <a:srgbClr val="556070"/>
                 </a:solidFill>
                 <a:latin typeface="Calibri"/>
               </a:rPr>
-              <a:t>Online Shoppers Purchase-Intention Capstone  |  kNN from Scratch</a:t>
-            </a:r>
+              <a:t>Online Shoppers Purchase-Intention Capstone  |  </a:t>
+            </a:r>
+            <a:r>
+              <a:rPr sz="1000" b="0" i="0" dirty="0" err="1">
+                <a:solidFill>
+                  <a:srgbClr val="556070"/>
+                </a:solidFill>
+                <a:latin typeface="Calibri"/>
+              </a:rPr>
+              <a:t>kN</a:t>
+            </a:r>
+            <a:r>
+              <a:rPr lang="en-US" sz="1000" b="0" i="0" dirty="0" err="1">
+                <a:solidFill>
+                  <a:srgbClr val="556070"/>
+                </a:solidFill>
+                <a:latin typeface="Calibri"/>
+              </a:rPr>
+              <a:t>N</a:t>
+            </a:r>
+            <a:endParaRPr sz="1000" b="0" i="0" dirty="0">
+              <a:solidFill>
+                <a:srgbClr val="556070"/>
+              </a:solidFill>
+              <a:latin typeface="Calibri"/>
+            </a:endParaRPr>
           </a:p>
         </p:txBody>
       </p:sp>
@@ -8391,7 +8460,7 @@
         <p:spPr>
           <a:xfrm>
             <a:off x="457200" y="6492240"/>
-            <a:ext cx="7315200" cy="274320"/>
+            <a:ext cx="7315200" cy="246221"/>
           </a:xfrm>
           <a:prstGeom prst="rect">
             <a:avLst/>
@@ -8406,14 +8475,29 @@
           <a:p>
             <a:pPr algn="l"/>
             <a:r>
-              <a:rPr sz="1000" b="0" i="0">
+              <a:rPr sz="1000" b="0" i="0" dirty="0">
                 <a:solidFill>
                   <a:srgbClr val="556070"/>
                 </a:solidFill>
                 <a:latin typeface="Calibri"/>
               </a:rPr>
-              <a:t>Online Shoppers Purchase-Intention Capstone  |  kNN from Scratch</a:t>
-            </a:r>
+              <a:t>Online Shoppers Purchase-Intention Capstone  |  </a:t>
+            </a:r>
+            <a:r>
+              <a:rPr sz="1000" b="0" i="0" dirty="0" err="1">
+                <a:solidFill>
+                  <a:srgbClr val="556070"/>
+                </a:solidFill>
+                <a:latin typeface="Calibri"/>
+              </a:rPr>
+              <a:t>kNN</a:t>
+            </a:r>
+            <a:endParaRPr sz="1000" b="0" i="0" dirty="0">
+              <a:solidFill>
+                <a:srgbClr val="556070"/>
+              </a:solidFill>
+              <a:latin typeface="Calibri"/>
+            </a:endParaRPr>
           </a:p>
         </p:txBody>
       </p:sp>
@@ -8909,7 +8993,7 @@
         <p:spPr>
           <a:xfrm>
             <a:off x="457200" y="6492240"/>
-            <a:ext cx="7315200" cy="274320"/>
+            <a:ext cx="7315200" cy="246221"/>
           </a:xfrm>
           <a:prstGeom prst="rect">
             <a:avLst/>
@@ -8924,14 +9008,29 @@
           <a:p>
             <a:pPr algn="l"/>
             <a:r>
-              <a:rPr sz="1000" b="0" i="0">
+              <a:rPr sz="1000" b="0" i="0" dirty="0">
                 <a:solidFill>
                   <a:srgbClr val="556070"/>
                 </a:solidFill>
                 <a:latin typeface="Calibri"/>
               </a:rPr>
-              <a:t>Online Shoppers Purchase-Intention Capstone  |  kNN from Scratch</a:t>
-            </a:r>
+              <a:t>Online Shoppers Purchase-Intention Capstone  |  </a:t>
+            </a:r>
+            <a:r>
+              <a:rPr sz="1000" b="0" i="0" dirty="0" err="1">
+                <a:solidFill>
+                  <a:srgbClr val="556070"/>
+                </a:solidFill>
+                <a:latin typeface="Calibri"/>
+              </a:rPr>
+              <a:t>kNN</a:t>
+            </a:r>
+            <a:endParaRPr sz="1000" b="0" i="0" dirty="0">
+              <a:solidFill>
+                <a:srgbClr val="556070"/>
+              </a:solidFill>
+              <a:latin typeface="Calibri"/>
+            </a:endParaRPr>
           </a:p>
         </p:txBody>
       </p:sp>
@@ -10097,7 +10196,7 @@
         <p:spPr>
           <a:xfrm>
             <a:off x="457200" y="6492240"/>
-            <a:ext cx="7315200" cy="274320"/>
+            <a:ext cx="7315200" cy="246221"/>
           </a:xfrm>
           <a:prstGeom prst="rect">
             <a:avLst/>
@@ -10112,14 +10211,29 @@
           <a:p>
             <a:pPr algn="l"/>
             <a:r>
-              <a:rPr sz="1000" b="0" i="0">
+              <a:rPr sz="1000" b="0" i="0" dirty="0">
                 <a:solidFill>
                   <a:srgbClr val="556070"/>
                 </a:solidFill>
                 <a:latin typeface="Calibri"/>
               </a:rPr>
-              <a:t>Online Shoppers Purchase-Intention Capstone  |  kNN from Scratch</a:t>
-            </a:r>
+              <a:t>Online Shoppers Purchase-Intention Capstone  |  </a:t>
+            </a:r>
+            <a:r>
+              <a:rPr sz="1000" b="0" i="0" dirty="0" err="1">
+                <a:solidFill>
+                  <a:srgbClr val="556070"/>
+                </a:solidFill>
+                <a:latin typeface="Calibri"/>
+              </a:rPr>
+              <a:t>kNN</a:t>
+            </a:r>
+            <a:endParaRPr sz="1000" b="0" i="0" dirty="0">
+              <a:solidFill>
+                <a:srgbClr val="556070"/>
+              </a:solidFill>
+              <a:latin typeface="Calibri"/>
+            </a:endParaRPr>
           </a:p>
         </p:txBody>
       </p:sp>
@@ -10753,7 +10867,7 @@
         <p:spPr>
           <a:xfrm>
             <a:off x="457200" y="6492240"/>
-            <a:ext cx="7315200" cy="274320"/>
+            <a:ext cx="7315200" cy="246221"/>
           </a:xfrm>
           <a:prstGeom prst="rect">
             <a:avLst/>
@@ -10768,14 +10882,29 @@
           <a:p>
             <a:pPr algn="l"/>
             <a:r>
-              <a:rPr sz="1000" b="0" i="0">
+              <a:rPr sz="1000" b="0" i="0" dirty="0">
                 <a:solidFill>
                   <a:srgbClr val="556070"/>
                 </a:solidFill>
                 <a:latin typeface="Calibri"/>
               </a:rPr>
-              <a:t>Online Shoppers Purchase-Intention Capstone  |  kNN from Scratch</a:t>
-            </a:r>
+              <a:t>Online Shoppers Purchase-Intention Capstone  |  </a:t>
+            </a:r>
+            <a:r>
+              <a:rPr sz="1000" b="0" i="0" dirty="0" err="1">
+                <a:solidFill>
+                  <a:srgbClr val="556070"/>
+                </a:solidFill>
+                <a:latin typeface="Calibri"/>
+              </a:rPr>
+              <a:t>kNN</a:t>
+            </a:r>
+            <a:endParaRPr sz="1000" b="0" i="0" dirty="0">
+              <a:solidFill>
+                <a:srgbClr val="556070"/>
+              </a:solidFill>
+              <a:latin typeface="Calibri"/>
+            </a:endParaRPr>
           </a:p>
         </p:txBody>
       </p:sp>
@@ -11769,7 +11898,7 @@
         <p:spPr>
           <a:xfrm>
             <a:off x="457200" y="6492240"/>
-            <a:ext cx="7315200" cy="274320"/>
+            <a:ext cx="7315200" cy="246221"/>
           </a:xfrm>
           <a:prstGeom prst="rect">
             <a:avLst/>
@@ -11784,14 +11913,29 @@
           <a:p>
             <a:pPr algn="l"/>
             <a:r>
-              <a:rPr sz="1000" b="0" i="0">
+              <a:rPr sz="1000" b="0" i="0" dirty="0">
                 <a:solidFill>
                   <a:srgbClr val="556070"/>
                 </a:solidFill>
                 <a:latin typeface="Calibri"/>
               </a:rPr>
-              <a:t>Online Shoppers Purchase-Intention Capstone  |  kNN from Scratch</a:t>
-            </a:r>
+              <a:t>Online Shoppers Purchase-Intention Capstone  |  </a:t>
+            </a:r>
+            <a:r>
+              <a:rPr sz="1000" b="0" i="0" dirty="0" err="1">
+                <a:solidFill>
+                  <a:srgbClr val="556070"/>
+                </a:solidFill>
+                <a:latin typeface="Calibri"/>
+              </a:rPr>
+              <a:t>kNN</a:t>
+            </a:r>
+            <a:endParaRPr sz="1000" b="0" i="0" dirty="0">
+              <a:solidFill>
+                <a:srgbClr val="556070"/>
+              </a:solidFill>
+              <a:latin typeface="Calibri"/>
+            </a:endParaRPr>
           </a:p>
         </p:txBody>
       </p:sp>
@@ -12995,7 +13139,7 @@
         <p:spPr>
           <a:xfrm>
             <a:off x="457200" y="6492240"/>
-            <a:ext cx="7315200" cy="274320"/>
+            <a:ext cx="7315200" cy="246221"/>
           </a:xfrm>
           <a:prstGeom prst="rect">
             <a:avLst/>
@@ -13010,14 +13154,29 @@
           <a:p>
             <a:pPr algn="l"/>
             <a:r>
-              <a:rPr sz="1000" b="0" i="0">
+              <a:rPr sz="1000" b="0" i="0" dirty="0">
                 <a:solidFill>
                   <a:srgbClr val="556070"/>
                 </a:solidFill>
                 <a:latin typeface="Calibri"/>
               </a:rPr>
-              <a:t>Online Shoppers Purchase-Intention Capstone  |  kNN from Scratch</a:t>
-            </a:r>
+              <a:t>Online Shoppers Purchase-Intention Capstone  |  </a:t>
+            </a:r>
+            <a:r>
+              <a:rPr sz="1000" b="0" i="0" dirty="0" err="1">
+                <a:solidFill>
+                  <a:srgbClr val="556070"/>
+                </a:solidFill>
+                <a:latin typeface="Calibri"/>
+              </a:rPr>
+              <a:t>kNN</a:t>
+            </a:r>
+            <a:endParaRPr sz="1000" b="0" i="0" dirty="0">
+              <a:solidFill>
+                <a:srgbClr val="556070"/>
+              </a:solidFill>
+              <a:latin typeface="Calibri"/>
+            </a:endParaRPr>
           </a:p>
         </p:txBody>
       </p:sp>
@@ -14677,7 +14836,7 @@
         <p:spPr>
           <a:xfrm>
             <a:off x="457200" y="6492240"/>
-            <a:ext cx="7315200" cy="274320"/>
+            <a:ext cx="7315200" cy="246221"/>
           </a:xfrm>
           <a:prstGeom prst="rect">
             <a:avLst/>
@@ -14692,14 +14851,29 @@
           <a:p>
             <a:pPr algn="l"/>
             <a:r>
-              <a:rPr sz="1000" b="0" i="0">
+              <a:rPr sz="1000" b="0" i="0" dirty="0">
                 <a:solidFill>
                   <a:srgbClr val="556070"/>
                 </a:solidFill>
                 <a:latin typeface="Calibri"/>
               </a:rPr>
-              <a:t>Online Shoppers Purchase-Intention Capstone  |  kNN from Scratch</a:t>
-            </a:r>
+              <a:t>Online Shoppers Purchase-Intention Capstone  |  </a:t>
+            </a:r>
+            <a:r>
+              <a:rPr sz="1000" b="0" i="0" dirty="0" err="1">
+                <a:solidFill>
+                  <a:srgbClr val="556070"/>
+                </a:solidFill>
+                <a:latin typeface="Calibri"/>
+              </a:rPr>
+              <a:t>kNN</a:t>
+            </a:r>
+            <a:endParaRPr sz="1000" b="0" i="0" dirty="0">
+              <a:solidFill>
+                <a:srgbClr val="556070"/>
+              </a:solidFill>
+              <a:latin typeface="Calibri"/>
+            </a:endParaRPr>
           </a:p>
         </p:txBody>
       </p:sp>
@@ -15580,7 +15754,7 @@
         <p:spPr>
           <a:xfrm>
             <a:off x="457200" y="6492240"/>
-            <a:ext cx="7315200" cy="274320"/>
+            <a:ext cx="7315200" cy="246221"/>
           </a:xfrm>
           <a:prstGeom prst="rect">
             <a:avLst/>
@@ -15595,14 +15769,29 @@
           <a:p>
             <a:pPr algn="l"/>
             <a:r>
-              <a:rPr sz="1000" b="0" i="0">
+              <a:rPr sz="1000" b="0" i="0" dirty="0">
                 <a:solidFill>
                   <a:srgbClr val="556070"/>
                 </a:solidFill>
                 <a:latin typeface="Calibri"/>
               </a:rPr>
-              <a:t>Online Shoppers Purchase-Intention Capstone  |  kNN from Scratch</a:t>
-            </a:r>
+              <a:t>Online Shoppers Purchase-Intention Capstone  |  </a:t>
+            </a:r>
+            <a:r>
+              <a:rPr sz="1000" b="0" i="0" dirty="0" err="1">
+                <a:solidFill>
+                  <a:srgbClr val="556070"/>
+                </a:solidFill>
+                <a:latin typeface="Calibri"/>
+              </a:rPr>
+              <a:t>kNN</a:t>
+            </a:r>
+            <a:endParaRPr sz="1000" b="0" i="0" dirty="0">
+              <a:solidFill>
+                <a:srgbClr val="556070"/>
+              </a:solidFill>
+              <a:latin typeface="Calibri"/>
+            </a:endParaRPr>
           </a:p>
         </p:txBody>
       </p:sp>
@@ -15834,7 +16023,7 @@
         <p:spPr>
           <a:xfrm>
             <a:off x="457200" y="4754880"/>
-            <a:ext cx="11247120" cy="457200"/>
+            <a:ext cx="11247120" cy="369332"/>
           </a:xfrm>
           <a:prstGeom prst="rect">
             <a:avLst/>
@@ -15849,49 +16038,29 @@
           <a:p>
             <a:pPr algn="ctr"/>
             <a:r>
-              <a:rPr sz="1800" b="0" i="0">
+              <a:rPr sz="1800" b="0" i="0" dirty="0">
                 <a:solidFill>
                   <a:srgbClr val="FFFFFF"/>
                 </a:solidFill>
                 <a:latin typeface="Calibri"/>
               </a:rPr>
-              <a:t>Predicting Online Shoppers’ Purchase Intention  •  kNN from Scratch</a:t>
-            </a:r>
-          </a:p>
-        </p:txBody>
-      </p:sp>
-      <p:sp>
-        <p:nvSpPr>
-          <p:cNvPr id="7" name="TextBox 6"/>
-          <p:cNvSpPr txBox="1"/>
-          <p:nvPr/>
-        </p:nvSpPr>
-        <p:spPr>
-          <a:xfrm>
-            <a:off x="457200" y="5303520"/>
-            <a:ext cx="11247120" cy="457200"/>
-          </a:xfrm>
-          <a:prstGeom prst="rect">
-            <a:avLst/>
-          </a:prstGeom>
-          <a:noFill/>
-        </p:spPr>
-        <p:txBody>
-          <a:bodyPr wrap="square" anchor="t">
-            <a:spAutoFit/>
-          </a:bodyPr>
-          <a:lstStyle/>
-          <a:p>
-            <a:pPr algn="ctr"/>
-            <a:r>
-              <a:rPr sz="1400" b="0" i="1">
+              <a:t>Predicting Online Shoppers’ Purchase Intention  •  </a:t>
+            </a:r>
+            <a:r>
+              <a:rPr sz="1800" b="0" i="0" dirty="0" err="1">
                 <a:solidFill>
                   <a:srgbClr val="FFFFFF"/>
                 </a:solidFill>
                 <a:latin typeface="Calibri"/>
               </a:rPr>
-              <a:t>Code, figures, and report bundled in the project folder.</a:t>
-            </a:r>
+              <a:t>kNN</a:t>
+            </a:r>
+            <a:endParaRPr sz="1800" b="0" i="0" dirty="0">
+              <a:solidFill>
+                <a:srgbClr val="FFFFFF"/>
+              </a:solidFill>
+              <a:latin typeface="Calibri"/>
+            </a:endParaRPr>
           </a:p>
         </p:txBody>
       </p:sp>
@@ -16509,7 +16678,7 @@
         <p:spPr>
           <a:xfrm>
             <a:off x="457200" y="6492240"/>
-            <a:ext cx="7315200" cy="274320"/>
+            <a:ext cx="7315200" cy="246221"/>
           </a:xfrm>
           <a:prstGeom prst="rect">
             <a:avLst/>
@@ -16524,14 +16693,29 @@
           <a:p>
             <a:pPr algn="l"/>
             <a:r>
-              <a:rPr sz="1000" b="0" i="0">
+              <a:rPr sz="1000" b="0" i="0" dirty="0">
                 <a:solidFill>
                   <a:srgbClr val="556070"/>
                 </a:solidFill>
                 <a:latin typeface="Calibri"/>
               </a:rPr>
-              <a:t>Online Shoppers Purchase-Intention Capstone  |  kNN from Scratch</a:t>
-            </a:r>
+              <a:t>Online Shoppers Purchase-Intention Capstone  |  </a:t>
+            </a:r>
+            <a:r>
+              <a:rPr sz="1000" b="0" i="0" dirty="0" err="1">
+                <a:solidFill>
+                  <a:srgbClr val="556070"/>
+                </a:solidFill>
+                <a:latin typeface="Calibri"/>
+              </a:rPr>
+              <a:t>kNN</a:t>
+            </a:r>
+            <a:endParaRPr sz="1000" b="0" i="0" dirty="0">
+              <a:solidFill>
+                <a:srgbClr val="556070"/>
+              </a:solidFill>
+              <a:latin typeface="Calibri"/>
+            </a:endParaRPr>
           </a:p>
         </p:txBody>
       </p:sp>
@@ -17974,7 +18158,7 @@
         <p:spPr>
           <a:xfrm>
             <a:off x="457200" y="6492240"/>
-            <a:ext cx="7315200" cy="274320"/>
+            <a:ext cx="7315200" cy="246221"/>
           </a:xfrm>
           <a:prstGeom prst="rect">
             <a:avLst/>
@@ -17989,14 +18173,29 @@
           <a:p>
             <a:pPr algn="l"/>
             <a:r>
-              <a:rPr sz="1000" b="0" i="0">
+              <a:rPr sz="1000" b="0" i="0" dirty="0">
                 <a:solidFill>
                   <a:srgbClr val="556070"/>
                 </a:solidFill>
                 <a:latin typeface="Calibri"/>
               </a:rPr>
-              <a:t>Online Shoppers Purchase-Intention Capstone  |  kNN from Scratch</a:t>
-            </a:r>
+              <a:t>Online Shoppers Purchase-Intention Capstone  |  </a:t>
+            </a:r>
+            <a:r>
+              <a:rPr sz="1000" b="0" i="0" dirty="0" err="1">
+                <a:solidFill>
+                  <a:srgbClr val="556070"/>
+                </a:solidFill>
+                <a:latin typeface="Calibri"/>
+              </a:rPr>
+              <a:t>kNN</a:t>
+            </a:r>
+            <a:endParaRPr sz="1000" b="0" i="0" dirty="0">
+              <a:solidFill>
+                <a:srgbClr val="556070"/>
+              </a:solidFill>
+              <a:latin typeface="Calibri"/>
+            </a:endParaRPr>
           </a:p>
         </p:txBody>
       </p:sp>
@@ -18511,7 +18710,7 @@
         <p:spPr>
           <a:xfrm>
             <a:off x="457200" y="6492240"/>
-            <a:ext cx="7315200" cy="274320"/>
+            <a:ext cx="7315200" cy="246221"/>
           </a:xfrm>
           <a:prstGeom prst="rect">
             <a:avLst/>
@@ -18526,14 +18725,29 @@
           <a:p>
             <a:pPr algn="l"/>
             <a:r>
-              <a:rPr sz="1000" b="0" i="0">
+              <a:rPr sz="1000" b="0" i="0" dirty="0">
                 <a:solidFill>
                   <a:srgbClr val="556070"/>
                 </a:solidFill>
                 <a:latin typeface="Calibri"/>
               </a:rPr>
-              <a:t>Online Shoppers Purchase-Intention Capstone  |  kNN from Scratch</a:t>
-            </a:r>
+              <a:t>Online Shoppers Purchase-Intention Capstone  |  </a:t>
+            </a:r>
+            <a:r>
+              <a:rPr sz="1000" b="0" i="0" dirty="0" err="1">
+                <a:solidFill>
+                  <a:srgbClr val="556070"/>
+                </a:solidFill>
+                <a:latin typeface="Calibri"/>
+              </a:rPr>
+              <a:t>kNN</a:t>
+            </a:r>
+            <a:endParaRPr sz="1000" b="0" i="0" dirty="0">
+              <a:solidFill>
+                <a:srgbClr val="556070"/>
+              </a:solidFill>
+              <a:latin typeface="Calibri"/>
+            </a:endParaRPr>
           </a:p>
         </p:txBody>
       </p:sp>
@@ -19106,7 +19320,7 @@
         <p:spPr>
           <a:xfrm>
             <a:off x="457200" y="6492240"/>
-            <a:ext cx="7315200" cy="274320"/>
+            <a:ext cx="7315200" cy="246221"/>
           </a:xfrm>
           <a:prstGeom prst="rect">
             <a:avLst/>
@@ -19121,14 +19335,29 @@
           <a:p>
             <a:pPr algn="l"/>
             <a:r>
-              <a:rPr sz="1000" b="0" i="0">
+              <a:rPr sz="1000" b="0" i="0" dirty="0">
                 <a:solidFill>
                   <a:srgbClr val="556070"/>
                 </a:solidFill>
                 <a:latin typeface="Calibri"/>
               </a:rPr>
-              <a:t>Online Shoppers Purchase-Intention Capstone  |  kNN from Scratch</a:t>
-            </a:r>
+              <a:t>Online Shoppers Purchase-Intention Capstone  |  </a:t>
+            </a:r>
+            <a:r>
+              <a:rPr lang="en-US" sz="1000" b="0" i="0" dirty="0" err="1">
+                <a:solidFill>
+                  <a:srgbClr val="556070"/>
+                </a:solidFill>
+                <a:latin typeface="Calibri"/>
+              </a:rPr>
+              <a:t>kNN</a:t>
+            </a:r>
+            <a:endParaRPr sz="1000" b="0" i="0" dirty="0">
+              <a:solidFill>
+                <a:srgbClr val="556070"/>
+              </a:solidFill>
+              <a:latin typeface="Calibri"/>
+            </a:endParaRPr>
           </a:p>
         </p:txBody>
       </p:sp>
@@ -19720,7 +19949,7 @@
         <p:spPr>
           <a:xfrm>
             <a:off x="457200" y="6492240"/>
-            <a:ext cx="7315200" cy="274320"/>
+            <a:ext cx="7315200" cy="246221"/>
           </a:xfrm>
           <a:prstGeom prst="rect">
             <a:avLst/>
@@ -19735,14 +19964,29 @@
           <a:p>
             <a:pPr algn="l"/>
             <a:r>
-              <a:rPr sz="1000" b="0" i="0">
+              <a:rPr sz="1000" b="0" i="0" dirty="0">
                 <a:solidFill>
                   <a:srgbClr val="556070"/>
                 </a:solidFill>
                 <a:latin typeface="Calibri"/>
               </a:rPr>
-              <a:t>Online Shoppers Purchase-Intention Capstone  |  kNN from Scratch</a:t>
-            </a:r>
+              <a:t>Online Shoppers Purchase-Intention Capstone  |  </a:t>
+            </a:r>
+            <a:r>
+              <a:rPr sz="1000" b="0" i="0" dirty="0" err="1">
+                <a:solidFill>
+                  <a:srgbClr val="556070"/>
+                </a:solidFill>
+                <a:latin typeface="Calibri"/>
+              </a:rPr>
+              <a:t>kNN</a:t>
+            </a:r>
+            <a:endParaRPr sz="1000" b="0" i="0" dirty="0">
+              <a:solidFill>
+                <a:srgbClr val="556070"/>
+              </a:solidFill>
+              <a:latin typeface="Calibri"/>
+            </a:endParaRPr>
           </a:p>
         </p:txBody>
       </p:sp>
@@ -20334,7 +20578,7 @@
         <p:spPr>
           <a:xfrm>
             <a:off x="457200" y="6492240"/>
-            <a:ext cx="7315200" cy="274320"/>
+            <a:ext cx="7315200" cy="246221"/>
           </a:xfrm>
           <a:prstGeom prst="rect">
             <a:avLst/>
@@ -20349,14 +20593,29 @@
           <a:p>
             <a:pPr algn="l"/>
             <a:r>
-              <a:rPr sz="1000" b="0" i="0">
+              <a:rPr sz="1000" b="0" i="0" dirty="0">
                 <a:solidFill>
                   <a:srgbClr val="556070"/>
                 </a:solidFill>
                 <a:latin typeface="Calibri"/>
               </a:rPr>
-              <a:t>Online Shoppers Purchase-Intention Capstone  |  kNN from Scratch</a:t>
-            </a:r>
+              <a:t>Online Shoppers Purchase-Intention Capstone  |  </a:t>
+            </a:r>
+            <a:r>
+              <a:rPr sz="1000" b="0" i="0" dirty="0" err="1">
+                <a:solidFill>
+                  <a:srgbClr val="556070"/>
+                </a:solidFill>
+                <a:latin typeface="Calibri"/>
+              </a:rPr>
+              <a:t>kNN</a:t>
+            </a:r>
+            <a:endParaRPr sz="1000" b="0" i="0" dirty="0">
+              <a:solidFill>
+                <a:srgbClr val="556070"/>
+              </a:solidFill>
+              <a:latin typeface="Calibri"/>
+            </a:endParaRPr>
           </a:p>
         </p:txBody>
       </p:sp>
@@ -20986,7 +21245,7 @@
         <p:spPr>
           <a:xfrm>
             <a:off x="457200" y="6492240"/>
-            <a:ext cx="7315200" cy="274320"/>
+            <a:ext cx="7315200" cy="246221"/>
           </a:xfrm>
           <a:prstGeom prst="rect">
             <a:avLst/>
@@ -21001,14 +21260,29 @@
           <a:p>
             <a:pPr algn="l"/>
             <a:r>
-              <a:rPr sz="1000" b="0" i="0">
+              <a:rPr sz="1000" b="0" i="0" dirty="0">
                 <a:solidFill>
                   <a:srgbClr val="556070"/>
                 </a:solidFill>
                 <a:latin typeface="Calibri"/>
               </a:rPr>
-              <a:t>Online Shoppers Purchase-Intention Capstone  |  kNN from Scratch</a:t>
-            </a:r>
+              <a:t>Online Shoppers Purchase-Intention Capstone  |  </a:t>
+            </a:r>
+            <a:r>
+              <a:rPr sz="1000" b="0" i="0" dirty="0" err="1">
+                <a:solidFill>
+                  <a:srgbClr val="556070"/>
+                </a:solidFill>
+                <a:latin typeface="Calibri"/>
+              </a:rPr>
+              <a:t>kNN</a:t>
+            </a:r>
+            <a:endParaRPr sz="1000" b="0" i="0" dirty="0">
+              <a:solidFill>
+                <a:srgbClr val="556070"/>
+              </a:solidFill>
+              <a:latin typeface="Calibri"/>
+            </a:endParaRPr>
           </a:p>
         </p:txBody>
       </p:sp>

</xml_diff>

<commit_message>
Choose k=7 in tuning plot and update README
Document selection of k=7 (precision-oriented) and related analysis: README updated with 5-fold CV stats, clarified that raw F1 peaks at k=3 but k=7 was chosen for higher precision, added detailed baseline comparison showing a single-feature PageValues rule outperforms kNN on F1/recall, and adjusted runtime notes. knn_tune_k.py updated to mark CHOSEN_K=7 and draw the chosen k on the performance plot. Updated presentation, report, and tuning figure binaries to match the revised writeups.
</commit_message>
<xml_diff>
--- a/Capstone_Presentation.pptx
+++ b/Capstone_Presentation.pptx
@@ -322,7 +322,7 @@
           <a:p>
             <a:fld id="{5BCAD085-E8A6-8845-BD4E-CB4CCA059FC4}" type="datetimeFigureOut">
               <a:rPr lang="en-US" smtClean="0"/>
-              <a:t>5/17/2026</a:t>
+              <a:t>5/21/2026</a:t>
             </a:fld>
             <a:endParaRPr lang="en-US"/>
           </a:p>
@@ -490,7 +490,7 @@
           <a:p>
             <a:fld id="{5BCAD085-E8A6-8845-BD4E-CB4CCA059FC4}" type="datetimeFigureOut">
               <a:rPr lang="en-US" smtClean="0"/>
-              <a:t>5/17/2026</a:t>
+              <a:t>5/21/2026</a:t>
             </a:fld>
             <a:endParaRPr lang="en-US"/>
           </a:p>
@@ -668,7 +668,7 @@
           <a:p>
             <a:fld id="{5BCAD085-E8A6-8845-BD4E-CB4CCA059FC4}" type="datetimeFigureOut">
               <a:rPr lang="en-US" smtClean="0"/>
-              <a:t>5/17/2026</a:t>
+              <a:t>5/21/2026</a:t>
             </a:fld>
             <a:endParaRPr lang="en-US"/>
           </a:p>
@@ -836,7 +836,7 @@
           <a:p>
             <a:fld id="{5BCAD085-E8A6-8845-BD4E-CB4CCA059FC4}" type="datetimeFigureOut">
               <a:rPr lang="en-US" smtClean="0"/>
-              <a:t>5/17/2026</a:t>
+              <a:t>5/21/2026</a:t>
             </a:fld>
             <a:endParaRPr lang="en-US"/>
           </a:p>
@@ -1081,7 +1081,7 @@
           <a:p>
             <a:fld id="{5BCAD085-E8A6-8845-BD4E-CB4CCA059FC4}" type="datetimeFigureOut">
               <a:rPr lang="en-US" smtClean="0"/>
-              <a:t>5/17/2026</a:t>
+              <a:t>5/21/2026</a:t>
             </a:fld>
             <a:endParaRPr lang="en-US"/>
           </a:p>
@@ -1366,7 +1366,7 @@
           <a:p>
             <a:fld id="{5BCAD085-E8A6-8845-BD4E-CB4CCA059FC4}" type="datetimeFigureOut">
               <a:rPr lang="en-US" smtClean="0"/>
-              <a:t>5/17/2026</a:t>
+              <a:t>5/21/2026</a:t>
             </a:fld>
             <a:endParaRPr lang="en-US"/>
           </a:p>
@@ -1785,7 +1785,7 @@
           <a:p>
             <a:fld id="{5BCAD085-E8A6-8845-BD4E-CB4CCA059FC4}" type="datetimeFigureOut">
               <a:rPr lang="en-US" smtClean="0"/>
-              <a:t>5/17/2026</a:t>
+              <a:t>5/21/2026</a:t>
             </a:fld>
             <a:endParaRPr lang="en-US"/>
           </a:p>
@@ -1902,7 +1902,7 @@
           <a:p>
             <a:fld id="{5BCAD085-E8A6-8845-BD4E-CB4CCA059FC4}" type="datetimeFigureOut">
               <a:rPr lang="en-US" smtClean="0"/>
-              <a:t>5/17/2026</a:t>
+              <a:t>5/21/2026</a:t>
             </a:fld>
             <a:endParaRPr lang="en-US"/>
           </a:p>
@@ -1997,7 +1997,7 @@
           <a:p>
             <a:fld id="{5BCAD085-E8A6-8845-BD4E-CB4CCA059FC4}" type="datetimeFigureOut">
               <a:rPr lang="en-US" smtClean="0"/>
-              <a:t>5/17/2026</a:t>
+              <a:t>5/21/2026</a:t>
             </a:fld>
             <a:endParaRPr lang="en-US"/>
           </a:p>
@@ -2272,7 +2272,7 @@
           <a:p>
             <a:fld id="{5BCAD085-E8A6-8845-BD4E-CB4CCA059FC4}" type="datetimeFigureOut">
               <a:rPr lang="en-US" smtClean="0"/>
-              <a:t>5/17/2026</a:t>
+              <a:t>5/21/2026</a:t>
             </a:fld>
             <a:endParaRPr lang="en-US"/>
           </a:p>
@@ -2524,7 +2524,7 @@
           <a:p>
             <a:fld id="{5BCAD085-E8A6-8845-BD4E-CB4CCA059FC4}" type="datetimeFigureOut">
               <a:rPr lang="en-US" smtClean="0"/>
-              <a:t>5/17/2026</a:t>
+              <a:t>5/21/2026</a:t>
             </a:fld>
             <a:endParaRPr lang="en-US"/>
           </a:p>
@@ -2735,7 +2735,7 @@
           <a:p>
             <a:fld id="{5BCAD085-E8A6-8845-BD4E-CB4CCA059FC4}" type="datetimeFigureOut">
               <a:rPr lang="en-US" smtClean="0"/>
-              <a:t>5/17/2026</a:t>
+              <a:t>5/21/2026</a:t>
             </a:fld>
             <a:endParaRPr lang="en-US"/>
           </a:p>
@@ -6913,7 +6913,7 @@
         <p:spPr>
           <a:xfrm>
             <a:off x="457200" y="1280160"/>
-            <a:ext cx="11247120" cy="365760"/>
+            <a:ext cx="11247120" cy="323165"/>
           </a:xfrm>
           <a:prstGeom prst="rect">
             <a:avLst/>
@@ -6928,14 +6928,20 @@
           <a:p>
             <a:pPr algn="l"/>
             <a:r>
-              <a:rPr sz="1500" b="0" i="1">
+              <a:rPr lang="en-US" sz="1500" b="0" i="1" dirty="0">
                 <a:solidFill>
                   <a:srgbClr val="556070"/>
                 </a:solidFill>
                 <a:latin typeface="Calibri"/>
               </a:rPr>
-              <a:t>F1 peaks at k = 7. Recall and precision pull in opposite directions.</a:t>
-            </a:r>
+              <a:t>F1 peaks at k = 3; we chose k = 7 for its higher precision. Recall and precision pull in opposite directions.</a:t>
+            </a:r>
+            <a:endParaRPr sz="1500" b="0" i="1" dirty="0">
+              <a:solidFill>
+                <a:srgbClr val="556070"/>
+              </a:solidFill>
+              <a:latin typeface="Calibri"/>
+            </a:endParaRPr>
           </a:p>
         </p:txBody>
       </p:sp>
@@ -6983,30 +6989,6 @@
           </a:p>
         </p:txBody>
       </p:sp>
-      <p:pic>
-        <p:nvPicPr>
-          <p:cNvPr id="8" name="Picture 7" descr="fig7_k_tuning.png"/>
-          <p:cNvPicPr>
-            <a:picLocks noChangeAspect="1"/>
-          </p:cNvPicPr>
-          <p:nvPr/>
-        </p:nvPicPr>
-        <p:blipFill>
-          <a:blip r:embed="rId2"/>
-          <a:stretch>
-            <a:fillRect/>
-          </a:stretch>
-        </p:blipFill>
-        <p:spPr>
-          <a:xfrm>
-            <a:off x="365760" y="1920240"/>
-            <a:ext cx="7315200" cy="3948596"/>
-          </a:xfrm>
-          <a:prstGeom prst="rect">
-            <a:avLst/>
-          </a:prstGeom>
-        </p:spPr>
-      </p:pic>
       <p:sp>
         <p:nvSpPr>
           <p:cNvPr id="9" name="Rounded Rectangle 8"/>
@@ -7097,8 +7079,8 @@
         </p:nvSpPr>
         <p:spPr>
           <a:xfrm>
-            <a:off x="8092440" y="2606040"/>
-            <a:ext cx="3566160" cy="2377440"/>
+            <a:off x="8046720" y="2614832"/>
+            <a:ext cx="3566160" cy="1536896"/>
           </a:xfrm>
           <a:prstGeom prst="rect">
             <a:avLst/>
@@ -7120,7 +7102,7 @@
               </a:spcAft>
             </a:pPr>
             <a:r>
-              <a:rPr sz="1300">
+              <a:rPr sz="1300" dirty="0">
                 <a:solidFill>
                   <a:srgbClr val="1A1A1A"/>
                 </a:solidFill>
@@ -7139,7 +7121,7 @@
               </a:spcAft>
             </a:pPr>
             <a:r>
-              <a:rPr sz="1300">
+              <a:rPr sz="1300" dirty="0">
                 <a:solidFill>
                   <a:srgbClr val="1A1A1A"/>
                 </a:solidFill>
@@ -7158,7 +7140,7 @@
               </a:spcAft>
             </a:pPr>
             <a:r>
-              <a:rPr sz="1300">
+              <a:rPr sz="1300" dirty="0">
                 <a:solidFill>
                   <a:srgbClr val="1A1A1A"/>
                 </a:solidFill>
@@ -7177,73 +7159,30 @@
               </a:spcAft>
             </a:pPr>
             <a:r>
-              <a:rPr sz="1300">
+              <a:rPr sz="1300" dirty="0">
                 <a:solidFill>
                   <a:srgbClr val="1A1A1A"/>
                 </a:solidFill>
                 <a:latin typeface="Calibri"/>
               </a:rPr>
-              <a:t>•  Best F1:         k = 7  ← chosen</a:t>
-            </a:r>
-          </a:p>
-        </p:txBody>
-      </p:sp>
-      <p:sp>
-        <p:nvSpPr>
-          <p:cNvPr id="12" name="TextBox 11"/>
-          <p:cNvSpPr txBox="1"/>
-          <p:nvPr/>
-        </p:nvSpPr>
-        <p:spPr>
-          <a:xfrm>
-            <a:off x="8092440" y="4572000"/>
-            <a:ext cx="3566160" cy="457200"/>
-          </a:xfrm>
-          <a:prstGeom prst="rect">
-            <a:avLst/>
-          </a:prstGeom>
-          <a:noFill/>
-        </p:spPr>
-        <p:txBody>
-          <a:bodyPr wrap="square" anchor="t">
-            <a:spAutoFit/>
-          </a:bodyPr>
-          <a:lstStyle/>
-          <a:p>
-            <a:pPr algn="l"/>
-            <a:r>
-              <a:rPr sz="1600" b="1" i="0">
-                <a:solidFill>
-                  <a:srgbClr val="DD8452"/>
-                </a:solidFill>
-                <a:latin typeface="Calibri"/>
-              </a:rPr>
-              <a:t>Why F1?</a:t>
-            </a:r>
-          </a:p>
-        </p:txBody>
-      </p:sp>
-      <p:sp>
-        <p:nvSpPr>
-          <p:cNvPr id="13" name="TextBox 12"/>
-          <p:cNvSpPr txBox="1"/>
-          <p:nvPr/>
-        </p:nvSpPr>
-        <p:spPr>
-          <a:xfrm>
-            <a:off x="8092440" y="5029200"/>
-            <a:ext cx="3566160" cy="1371600"/>
-          </a:xfrm>
-          <a:prstGeom prst="rect">
-            <a:avLst/>
-          </a:prstGeom>
-          <a:noFill/>
-        </p:spPr>
-        <p:txBody>
-          <a:bodyPr wrap="square">
-            <a:spAutoFit/>
-          </a:bodyPr>
-          <a:lstStyle/>
+              <a:t>•  Best F1:         k = </a:t>
+            </a:r>
+            <a:r>
+              <a:rPr lang="en-PH" sz="1300" dirty="0">
+                <a:solidFill>
+                  <a:srgbClr val="1A1A1A"/>
+                </a:solidFill>
+                <a:latin typeface="Calibri"/>
+              </a:rPr>
+              <a:t>3</a:t>
+            </a:r>
+            <a:endParaRPr lang="en-US" sz="1300" dirty="0">
+              <a:solidFill>
+                <a:srgbClr val="1A1A1A"/>
+              </a:solidFill>
+              <a:latin typeface="Calibri"/>
+            </a:endParaRPr>
+          </a:p>
           <a:p>
             <a:pPr algn="l">
               <a:lnSpc>
@@ -7254,15 +7193,85 @@
               </a:spcAft>
             </a:pPr>
             <a:r>
-              <a:rPr sz="1200">
+              <a:rPr lang="en-US" sz="1300" dirty="0">
                 <a:solidFill>
                   <a:srgbClr val="1A1A1A"/>
                 </a:solidFill>
                 <a:latin typeface="Calibri"/>
               </a:rPr>
-              <a:t>•  Balances precision and recall.</a:t>
-            </a:r>
-          </a:p>
+              <a:t>Chosen:             k = 7 (higher precision)</a:t>
+            </a:r>
+            <a:endParaRPr sz="1300" dirty="0">
+              <a:solidFill>
+                <a:srgbClr val="1A1A1A"/>
+              </a:solidFill>
+              <a:latin typeface="Calibri"/>
+            </a:endParaRPr>
+          </a:p>
+        </p:txBody>
+      </p:sp>
+      <p:sp>
+        <p:nvSpPr>
+          <p:cNvPr id="12" name="TextBox 11"/>
+          <p:cNvSpPr txBox="1"/>
+          <p:nvPr/>
+        </p:nvSpPr>
+        <p:spPr>
+          <a:xfrm>
+            <a:off x="8092440" y="4572000"/>
+            <a:ext cx="3566160" cy="338554"/>
+          </a:xfrm>
+          <a:prstGeom prst="rect">
+            <a:avLst/>
+          </a:prstGeom>
+          <a:noFill/>
+        </p:spPr>
+        <p:txBody>
+          <a:bodyPr wrap="square" anchor="t">
+            <a:spAutoFit/>
+          </a:bodyPr>
+          <a:lstStyle/>
+          <a:p>
+            <a:pPr algn="l"/>
+            <a:r>
+              <a:rPr lang="en-PH" sz="1600" b="1" i="0" dirty="0">
+                <a:solidFill>
+                  <a:srgbClr val="DD8452"/>
+                </a:solidFill>
+                <a:latin typeface="Calibri"/>
+              </a:rPr>
+              <a:t>How we chose k</a:t>
+            </a:r>
+            <a:endParaRPr sz="1600" b="1" i="0" dirty="0">
+              <a:solidFill>
+                <a:srgbClr val="DD8452"/>
+              </a:solidFill>
+              <a:latin typeface="Calibri"/>
+            </a:endParaRPr>
+          </a:p>
+        </p:txBody>
+      </p:sp>
+      <p:sp>
+        <p:nvSpPr>
+          <p:cNvPr id="13" name="TextBox 12"/>
+          <p:cNvSpPr txBox="1"/>
+          <p:nvPr/>
+        </p:nvSpPr>
+        <p:spPr>
+          <a:xfrm>
+            <a:off x="8092440" y="5029200"/>
+            <a:ext cx="3566160" cy="1006301"/>
+          </a:xfrm>
+          <a:prstGeom prst="rect">
+            <a:avLst/>
+          </a:prstGeom>
+          <a:noFill/>
+        </p:spPr>
+        <p:txBody>
+          <a:bodyPr wrap="square">
+            <a:spAutoFit/>
+          </a:bodyPr>
+          <a:lstStyle/>
           <a:p>
             <a:pPr algn="l">
               <a:lnSpc>
@@ -7273,14 +7282,57 @@
               </a:spcAft>
             </a:pPr>
             <a:r>
-              <a:rPr sz="1200">
+              <a:rPr sz="1200" dirty="0">
                 <a:solidFill>
                   <a:srgbClr val="1A1A1A"/>
                 </a:solidFill>
                 <a:latin typeface="Calibri"/>
               </a:rPr>
-              <a:t>•  The right metric when both false positives and false negatives matter.</a:t>
-            </a:r>
+              <a:t>•  </a:t>
+            </a:r>
+            <a:r>
+              <a:rPr lang="en-US" sz="1200" dirty="0">
+                <a:solidFill>
+                  <a:srgbClr val="1A1A1A"/>
+                </a:solidFill>
+                <a:latin typeface="Calibri"/>
+              </a:rPr>
+              <a:t>F1 to find the peak region (k ≈ 3–9), avoiding both extremes.</a:t>
+            </a:r>
+          </a:p>
+          <a:p>
+            <a:pPr algn="l">
+              <a:lnSpc>
+                <a:spcPct val="115000"/>
+              </a:lnSpc>
+              <a:spcAft>
+                <a:spcPts val="600"/>
+              </a:spcAft>
+            </a:pPr>
+            <a:r>
+              <a:rPr sz="1200" dirty="0">
+                <a:solidFill>
+                  <a:srgbClr val="1A1A1A"/>
+                </a:solidFill>
+                <a:latin typeface="Calibri"/>
+              </a:rPr>
+              <a:t>•  </a:t>
+            </a:r>
+            <a:r>
+              <a:rPr lang="en-US" sz="1200" dirty="0">
+                <a:solidFill>
+                  <a:srgbClr val="1A1A1A"/>
+                </a:solidFill>
+                <a:latin typeface="Calibri"/>
+              </a:rPr>
+              <a:t>Precision to pick within it → k = 7 — a confident, conservative classifier.</a:t>
+            </a:r>
+            <a:endParaRPr sz="1200" dirty="0">
+              <a:solidFill>
+                <a:srgbClr val="1A1A1A"/>
+              </a:solidFill>
+              <a:latin typeface="Calibri"/>
+            </a:endParaRPr>
           </a:p>
         </p:txBody>
       </p:sp>
@@ -7378,6 +7430,36 @@
           </a:p>
         </p:txBody>
       </p:sp>
+      <p:pic>
+        <p:nvPicPr>
+          <p:cNvPr id="17" name="Picture 16">
+            <a:extLst>
+              <a:ext uri="{FF2B5EF4-FFF2-40B4-BE49-F238E27FC236}">
+                <a16:creationId xmlns:a16="http://schemas.microsoft.com/office/drawing/2014/main" id="{F1B267E2-0090-66C2-4F43-9A070DDC2241}"/>
+              </a:ext>
+            </a:extLst>
+          </p:cNvPr>
+          <p:cNvPicPr>
+            <a:picLocks noChangeAspect="1"/>
+          </p:cNvPicPr>
+          <p:nvPr/>
+        </p:nvPicPr>
+        <p:blipFill>
+          <a:blip r:embed="rId2"/>
+          <a:stretch>
+            <a:fillRect/>
+          </a:stretch>
+        </p:blipFill>
+        <p:spPr>
+          <a:xfrm>
+            <a:off x="457200" y="1904729"/>
+            <a:ext cx="7315200" cy="3948596"/>
+          </a:xfrm>
+          <a:prstGeom prst="rect">
+            <a:avLst/>
+          </a:prstGeom>
+        </p:spPr>
+      </p:pic>
     </p:spTree>
   </p:cSld>
   <p:clrMapOvr>
@@ -8800,7 +8882,7 @@
       </p:sp>
       <p:pic>
         <p:nvPicPr>
-          <p:cNvPr id="8" name="Picture 7" descr="fig8_final_confusion_matrix.png"/>
+          <p:cNvPr id="8" name="Picture 7"/>
           <p:cNvPicPr>
             <a:picLocks noChangeAspect="1"/>
           </p:cNvPicPr>
@@ -8808,14 +8890,13 @@
         </p:nvPicPr>
         <p:blipFill>
           <a:blip r:embed="rId2"/>
-          <a:stretch>
-            <a:fillRect/>
-          </a:stretch>
+          <a:srcRect/>
+          <a:stretch/>
         </p:blipFill>
         <p:spPr>
           <a:xfrm>
             <a:off x="365760" y="1920240"/>
-            <a:ext cx="8229600" cy="2886678"/>
+            <a:ext cx="8229599" cy="2886678"/>
           </a:xfrm>
           <a:prstGeom prst="rect">
             <a:avLst/>
@@ -9226,7 +9307,7 @@
         <p:spPr>
           <a:xfrm>
             <a:off x="457200" y="685800"/>
-            <a:ext cx="11247120" cy="640080"/>
+            <a:ext cx="11247120" cy="553998"/>
           </a:xfrm>
           <a:prstGeom prst="rect">
             <a:avLst/>
@@ -9241,14 +9322,20 @@
           <a:p>
             <a:pPr algn="l"/>
             <a:r>
-              <a:rPr sz="3000" b="1" i="0">
+              <a:rPr lang="en-US" sz="3000" b="1" i="0" dirty="0">
                 <a:solidFill>
                   <a:srgbClr val="1F3A5F"/>
                 </a:solidFill>
                 <a:latin typeface="Calibri"/>
               </a:rPr>
-              <a:t>Validation: Stable Across Folds, and Beats the Baselines</a:t>
-            </a:r>
+              <a:t>Validation: Stable Across Folds — but a Simple Rule Beats Us</a:t>
+            </a:r>
+            <a:endParaRPr sz="3000" b="1" i="0" dirty="0">
+              <a:solidFill>
+                <a:srgbClr val="1F3A5F"/>
+              </a:solidFill>
+              <a:latin typeface="Calibri"/>
+            </a:endParaRPr>
           </a:p>
         </p:txBody>
       </p:sp>
@@ -9261,7 +9348,7 @@
         <p:spPr>
           <a:xfrm>
             <a:off x="457200" y="1280160"/>
-            <a:ext cx="11247120" cy="365760"/>
+            <a:ext cx="11247120" cy="323165"/>
           </a:xfrm>
           <a:prstGeom prst="rect">
             <a:avLst/>
@@ -9276,14 +9363,56 @@
           <a:p>
             <a:pPr algn="l"/>
             <a:r>
-              <a:rPr sz="1500" b="0" i="1">
+              <a:rPr lang="en-US" sz="1500" b="0" i="1" dirty="0">
                 <a:solidFill>
                   <a:srgbClr val="556070"/>
                 </a:solidFill>
                 <a:latin typeface="Calibri"/>
               </a:rPr>
-              <a:t>5-fold stratified CV plus two principled baselines confirm the result is real.</a:t>
-            </a:r>
+              <a:t>5-fold stratified CV confirms stability; but a one-feature </a:t>
+            </a:r>
+            <a:r>
+              <a:rPr lang="en-US" sz="1500" b="0" i="1" dirty="0" err="1">
+                <a:solidFill>
+                  <a:srgbClr val="556070"/>
+                </a:solidFill>
+                <a:latin typeface="Calibri"/>
+              </a:rPr>
+              <a:t>PageValues</a:t>
+            </a:r>
+            <a:r>
+              <a:rPr lang="en-US" sz="1500" b="0" i="1" dirty="0">
+                <a:solidFill>
+                  <a:srgbClr val="556070"/>
+                </a:solidFill>
+                <a:latin typeface="Calibri"/>
+              </a:rPr>
+              <a:t> rule outperforms our </a:t>
+            </a:r>
+            <a:r>
+              <a:rPr lang="en-US" sz="1500" b="0" i="1" dirty="0" err="1">
+                <a:solidFill>
+                  <a:srgbClr val="556070"/>
+                </a:solidFill>
+                <a:latin typeface="Calibri"/>
+              </a:rPr>
+              <a:t>kNN</a:t>
+            </a:r>
+            <a:r>
+              <a:rPr lang="en-US" sz="1500" b="0" i="1" dirty="0">
+                <a:solidFill>
+                  <a:srgbClr val="556070"/>
+                </a:solidFill>
+                <a:latin typeface="Calibri"/>
+              </a:rPr>
+              <a:t>.</a:t>
+            </a:r>
+            <a:endParaRPr sz="1500" b="0" i="1" dirty="0">
+              <a:solidFill>
+                <a:srgbClr val="556070"/>
+              </a:solidFill>
+              <a:latin typeface="Calibri"/>
+            </a:endParaRPr>
           </a:p>
         </p:txBody>
       </p:sp>
@@ -9444,7 +9573,7 @@
               </a:spcAft>
             </a:pPr>
             <a:r>
-              <a:rPr sz="1300">
+              <a:rPr sz="1300" dirty="0">
                 <a:solidFill>
                   <a:srgbClr val="1A1A1A"/>
                 </a:solidFill>
@@ -9463,7 +9592,7 @@
               </a:spcAft>
             </a:pPr>
             <a:r>
-              <a:rPr sz="1300">
+              <a:rPr sz="1300" dirty="0">
                 <a:solidFill>
                   <a:srgbClr val="1A1A1A"/>
                 </a:solidFill>
@@ -9482,7 +9611,7 @@
               </a:spcAft>
             </a:pPr>
             <a:r>
-              <a:rPr sz="1300">
+              <a:rPr sz="1300" dirty="0">
                 <a:solidFill>
                   <a:srgbClr val="1A1A1A"/>
                 </a:solidFill>
@@ -9501,7 +9630,7 @@
               </a:spcAft>
             </a:pPr>
             <a:r>
-              <a:rPr sz="1300">
+              <a:rPr sz="1300" dirty="0">
                 <a:solidFill>
                   <a:srgbClr val="1A1A1A"/>
                 </a:solidFill>
@@ -10161,7 +10290,7 @@
         <p:spPr>
           <a:xfrm>
             <a:off x="6400800" y="4754880"/>
-            <a:ext cx="5212080" cy="1280160"/>
+            <a:ext cx="5212080" cy="646331"/>
           </a:xfrm>
           <a:prstGeom prst="rect">
             <a:avLst/>
@@ -10176,14 +10305,83 @@
           <a:p>
             <a:pPr algn="l"/>
             <a:r>
-              <a:rPr sz="1200" b="0" i="1">
+              <a:rPr lang="en-US" sz="1200" b="0" i="1" dirty="0" err="1">
                 <a:solidFill>
                   <a:srgbClr val="556070"/>
                 </a:solidFill>
                 <a:latin typeface="Calibri"/>
               </a:rPr>
-              <a:t>kNN beats both baselines on F1 — a real signal, not memorization of one dominant feature.</a:t>
-            </a:r>
+              <a:t>kNN</a:t>
+            </a:r>
+            <a:r>
+              <a:rPr lang="en-US" sz="1200" b="0" i="1" dirty="0">
+                <a:solidFill>
+                  <a:srgbClr val="556070"/>
+                </a:solidFill>
+                <a:latin typeface="Calibri"/>
+              </a:rPr>
+              <a:t> beats both baselines on F1 — a real signal… → The </a:t>
+            </a:r>
+            <a:r>
+              <a:rPr lang="en-US" sz="1200" b="0" i="1" dirty="0" err="1">
+                <a:solidFill>
+                  <a:srgbClr val="556070"/>
+                </a:solidFill>
+                <a:latin typeface="Calibri"/>
+              </a:rPr>
+              <a:t>PageValues</a:t>
+            </a:r>
+            <a:r>
+              <a:rPr lang="en-US" sz="1200" b="0" i="1" dirty="0">
+                <a:solidFill>
+                  <a:srgbClr val="556070"/>
+                </a:solidFill>
+                <a:latin typeface="Calibri"/>
+              </a:rPr>
+              <a:t> rule beats </a:t>
+            </a:r>
+            <a:r>
+              <a:rPr lang="en-US" sz="1200" b="0" i="1" dirty="0" err="1">
+                <a:solidFill>
+                  <a:srgbClr val="556070"/>
+                </a:solidFill>
+                <a:latin typeface="Calibri"/>
+              </a:rPr>
+              <a:t>kNN</a:t>
+            </a:r>
+            <a:r>
+              <a:rPr lang="en-US" sz="1200" b="0" i="1" dirty="0">
+                <a:solidFill>
+                  <a:srgbClr val="556070"/>
+                </a:solidFill>
+                <a:latin typeface="Calibri"/>
+              </a:rPr>
+              <a:t> on F1 — </a:t>
+            </a:r>
+            <a:r>
+              <a:rPr lang="en-US" sz="1200" b="0" i="1" dirty="0" err="1">
+                <a:solidFill>
+                  <a:srgbClr val="556070"/>
+                </a:solidFill>
+                <a:latin typeface="Calibri"/>
+              </a:rPr>
+              <a:t>kNN</a:t>
+            </a:r>
+            <a:r>
+              <a:rPr lang="en-US" sz="1200" b="0" i="1" dirty="0">
+                <a:solidFill>
+                  <a:srgbClr val="556070"/>
+                </a:solidFill>
+                <a:latin typeface="Calibri"/>
+              </a:rPr>
+              <a:t> dilutes the dominant signal across 28 features. A humbling, instructive result.</a:t>
+            </a:r>
+            <a:endParaRPr sz="1200" b="0" i="1" dirty="0">
+              <a:solidFill>
+                <a:srgbClr val="556070"/>
+              </a:solidFill>
+              <a:latin typeface="Calibri"/>
+            </a:endParaRPr>
           </a:p>
         </p:txBody>
       </p:sp>
@@ -11150,7 +11348,7 @@
           <a:p>
             <a:pPr algn="l"/>
             <a:r>
-              <a:rPr sz="1500" b="0" i="1">
+              <a:rPr sz="1500" b="0" i="1" dirty="0">
                 <a:solidFill>
                   <a:srgbClr val="556070"/>
                 </a:solidFill>
@@ -11308,7 +11506,7 @@
           <a:p>
             <a:pPr algn="l"/>
             <a:r>
-              <a:rPr sz="1200" b="0" i="0">
+              <a:rPr sz="1200" b="0" i="0" dirty="0">
                 <a:solidFill>
                   <a:srgbClr val="1A1A1A"/>
                 </a:solidFill>
@@ -11536,7 +11734,7 @@
           <a:p>
             <a:pPr algn="l"/>
             <a:r>
-              <a:rPr sz="1200" b="0" i="0">
+              <a:rPr sz="1200" b="0" i="0" dirty="0">
                 <a:solidFill>
                   <a:srgbClr val="1A1A1A"/>
                 </a:solidFill>
@@ -11599,8 +11797,8 @@
         </p:nvSpPr>
         <p:spPr>
           <a:xfrm>
-            <a:off x="731520" y="4105656"/>
-            <a:ext cx="3108960" cy="640080"/>
+            <a:off x="731520" y="4148697"/>
+            <a:ext cx="3108960" cy="553998"/>
           </a:xfrm>
           <a:prstGeom prst="rect">
             <a:avLst/>
@@ -11615,14 +11813,38 @@
           <a:p>
             <a:pPr algn="l"/>
             <a:r>
-              <a:rPr sz="1500" b="1" i="0">
+              <a:rPr lang="en-US" sz="1500" b="1" i="0" dirty="0">
                 <a:solidFill>
                   <a:srgbClr val="1F3A5F"/>
                 </a:solidFill>
                 <a:latin typeface="Calibri"/>
               </a:rPr>
-              <a:t>k tuned on the test set</a:t>
-            </a:r>
+              <a:t>A one-feature </a:t>
+            </a:r>
+            <a:r>
+              <a:rPr lang="en-US" sz="1500" b="1" i="0" dirty="0" err="1">
+                <a:solidFill>
+                  <a:srgbClr val="1F3A5F"/>
+                </a:solidFill>
+                <a:latin typeface="Calibri"/>
+              </a:rPr>
+              <a:t>PageValues</a:t>
+            </a:r>
+            <a:r>
+              <a:rPr lang="en-US" sz="1500" b="1" i="0" dirty="0">
+                <a:solidFill>
+                  <a:srgbClr val="1F3A5F"/>
+                </a:solidFill>
+                <a:latin typeface="Calibri"/>
+              </a:rPr>
+              <a:t> rule beats the full model </a:t>
+            </a:r>
+            <a:endParaRPr sz="1500" b="1" i="0" dirty="0">
+              <a:solidFill>
+                <a:srgbClr val="1F3A5F"/>
+              </a:solidFill>
+              <a:latin typeface="Calibri"/>
+            </a:endParaRPr>
           </a:p>
         </p:txBody>
       </p:sp>
@@ -11634,8 +11856,8 @@
         </p:nvSpPr>
         <p:spPr>
           <a:xfrm>
-            <a:off x="3931920" y="4105656"/>
-            <a:ext cx="7772400" cy="640080"/>
+            <a:off x="3931920" y="4287196"/>
+            <a:ext cx="7772400" cy="276999"/>
           </a:xfrm>
           <a:prstGeom prst="rect">
             <a:avLst/>
@@ -11650,14 +11872,29 @@
           <a:p>
             <a:pPr algn="l"/>
             <a:r>
-              <a:rPr sz="1200" b="0" i="0">
+              <a:rPr lang="en-US" sz="1200" b="0" i="0" dirty="0" err="1">
                 <a:solidFill>
                   <a:srgbClr val="1A1A1A"/>
                 </a:solidFill>
                 <a:latin typeface="Calibri"/>
               </a:rPr>
-              <a:t>Best F1 was selected directly on the test set. A clean protocol would use a separate validation split. CV partially mitigates this.</a:t>
-            </a:r>
+              <a:t>kNN</a:t>
+            </a:r>
+            <a:r>
+              <a:rPr lang="en-US" sz="1200" b="0" i="0" dirty="0">
+                <a:solidFill>
+                  <a:srgbClr val="1A1A1A"/>
+                </a:solidFill>
+                <a:latin typeface="Calibri"/>
+              </a:rPr>
+              <a:t> doesn't do feature selection.</a:t>
+            </a:r>
+            <a:endParaRPr sz="1200" b="0" i="0" dirty="0">
+              <a:solidFill>
+                <a:srgbClr val="1A1A1A"/>
+              </a:solidFill>
+              <a:latin typeface="Calibri"/>
+            </a:endParaRPr>
           </a:p>
         </p:txBody>
       </p:sp>

</xml_diff>

<commit_message>
Update capstone presentation and report
Replace updated Capstone_Presentation.pptx and Capstone_Report.docx with revised content and formatting for the final submission. These binary updates include edits to slides and the project report (content/structure/formatting improvements).
</commit_message>
<xml_diff>
--- a/Capstone_Presentation.pptx
+++ b/Capstone_Presentation.pptx
@@ -15,17 +15,17 @@
     <p:sldId id="263" r:id="rId9"/>
     <p:sldId id="264" r:id="rId10"/>
     <p:sldId id="265" r:id="rId11"/>
-    <p:sldId id="266" r:id="rId12"/>
-    <p:sldId id="267" r:id="rId13"/>
-    <p:sldId id="268" r:id="rId14"/>
-    <p:sldId id="269" r:id="rId15"/>
-    <p:sldId id="270" r:id="rId16"/>
-    <p:sldId id="271" r:id="rId17"/>
-    <p:sldId id="272" r:id="rId18"/>
-    <p:sldId id="273" r:id="rId19"/>
-    <p:sldId id="274" r:id="rId20"/>
-    <p:sldId id="275" r:id="rId21"/>
-    <p:sldId id="276" r:id="rId22"/>
+    <p:sldId id="267" r:id="rId12"/>
+    <p:sldId id="268" r:id="rId13"/>
+    <p:sldId id="269" r:id="rId14"/>
+    <p:sldId id="270" r:id="rId15"/>
+    <p:sldId id="271" r:id="rId16"/>
+    <p:sldId id="272" r:id="rId17"/>
+    <p:sldId id="273" r:id="rId18"/>
+    <p:sldId id="274" r:id="rId19"/>
+    <p:sldId id="275" r:id="rId20"/>
+    <p:sldId id="276" r:id="rId21"/>
+    <p:sldId id="277" r:id="rId22"/>
   </p:sldIdLst>
   <p:sldSz cx="12192000" cy="6858000"/>
   <p:notesSz cx="6858000" cy="9144000"/>
@@ -322,7 +322,7 @@
           <a:p>
             <a:fld id="{5BCAD085-E8A6-8845-BD4E-CB4CCA059FC4}" type="datetimeFigureOut">
               <a:rPr lang="en-US" smtClean="0"/>
-              <a:t>5/21/2026</a:t>
+              <a:t>5/22/2026</a:t>
             </a:fld>
             <a:endParaRPr lang="en-US"/>
           </a:p>
@@ -490,7 +490,7 @@
           <a:p>
             <a:fld id="{5BCAD085-E8A6-8845-BD4E-CB4CCA059FC4}" type="datetimeFigureOut">
               <a:rPr lang="en-US" smtClean="0"/>
-              <a:t>5/21/2026</a:t>
+              <a:t>5/22/2026</a:t>
             </a:fld>
             <a:endParaRPr lang="en-US"/>
           </a:p>
@@ -668,7 +668,7 @@
           <a:p>
             <a:fld id="{5BCAD085-E8A6-8845-BD4E-CB4CCA059FC4}" type="datetimeFigureOut">
               <a:rPr lang="en-US" smtClean="0"/>
-              <a:t>5/21/2026</a:t>
+              <a:t>5/22/2026</a:t>
             </a:fld>
             <a:endParaRPr lang="en-US"/>
           </a:p>
@@ -836,7 +836,7 @@
           <a:p>
             <a:fld id="{5BCAD085-E8A6-8845-BD4E-CB4CCA059FC4}" type="datetimeFigureOut">
               <a:rPr lang="en-US" smtClean="0"/>
-              <a:t>5/21/2026</a:t>
+              <a:t>5/22/2026</a:t>
             </a:fld>
             <a:endParaRPr lang="en-US"/>
           </a:p>
@@ -1081,7 +1081,7 @@
           <a:p>
             <a:fld id="{5BCAD085-E8A6-8845-BD4E-CB4CCA059FC4}" type="datetimeFigureOut">
               <a:rPr lang="en-US" smtClean="0"/>
-              <a:t>5/21/2026</a:t>
+              <a:t>5/22/2026</a:t>
             </a:fld>
             <a:endParaRPr lang="en-US"/>
           </a:p>
@@ -1366,7 +1366,7 @@
           <a:p>
             <a:fld id="{5BCAD085-E8A6-8845-BD4E-CB4CCA059FC4}" type="datetimeFigureOut">
               <a:rPr lang="en-US" smtClean="0"/>
-              <a:t>5/21/2026</a:t>
+              <a:t>5/22/2026</a:t>
             </a:fld>
             <a:endParaRPr lang="en-US"/>
           </a:p>
@@ -1785,7 +1785,7 @@
           <a:p>
             <a:fld id="{5BCAD085-E8A6-8845-BD4E-CB4CCA059FC4}" type="datetimeFigureOut">
               <a:rPr lang="en-US" smtClean="0"/>
-              <a:t>5/21/2026</a:t>
+              <a:t>5/22/2026</a:t>
             </a:fld>
             <a:endParaRPr lang="en-US"/>
           </a:p>
@@ -1902,7 +1902,7 @@
           <a:p>
             <a:fld id="{5BCAD085-E8A6-8845-BD4E-CB4CCA059FC4}" type="datetimeFigureOut">
               <a:rPr lang="en-US" smtClean="0"/>
-              <a:t>5/21/2026</a:t>
+              <a:t>5/22/2026</a:t>
             </a:fld>
             <a:endParaRPr lang="en-US"/>
           </a:p>
@@ -1997,7 +1997,7 @@
           <a:p>
             <a:fld id="{5BCAD085-E8A6-8845-BD4E-CB4CCA059FC4}" type="datetimeFigureOut">
               <a:rPr lang="en-US" smtClean="0"/>
-              <a:t>5/21/2026</a:t>
+              <a:t>5/22/2026</a:t>
             </a:fld>
             <a:endParaRPr lang="en-US"/>
           </a:p>
@@ -2272,7 +2272,7 @@
           <a:p>
             <a:fld id="{5BCAD085-E8A6-8845-BD4E-CB4CCA059FC4}" type="datetimeFigureOut">
               <a:rPr lang="en-US" smtClean="0"/>
-              <a:t>5/21/2026</a:t>
+              <a:t>5/22/2026</a:t>
             </a:fld>
             <a:endParaRPr lang="en-US"/>
           </a:p>
@@ -2524,7 +2524,7 @@
           <a:p>
             <a:fld id="{5BCAD085-E8A6-8845-BD4E-CB4CCA059FC4}" type="datetimeFigureOut">
               <a:rPr lang="en-US" smtClean="0"/>
-              <a:t>5/21/2026</a:t>
+              <a:t>5/22/2026</a:t>
             </a:fld>
             <a:endParaRPr lang="en-US"/>
           </a:p>
@@ -2735,7 +2735,7 @@
           <a:p>
             <a:fld id="{5BCAD085-E8A6-8845-BD4E-CB4CCA059FC4}" type="datetimeFigureOut">
               <a:rPr lang="en-US" smtClean="0"/>
-              <a:t>5/21/2026</a:t>
+              <a:t>5/22/2026</a:t>
             </a:fld>
             <a:endParaRPr lang="en-US"/>
           </a:p>
@@ -3289,8 +3289,8 @@
         </p:nvSpPr>
         <p:spPr>
           <a:xfrm>
-            <a:off x="457200" y="3243887"/>
-            <a:ext cx="11247120" cy="461665"/>
+            <a:off x="457200" y="2926080"/>
+            <a:ext cx="11247120" cy="1097280"/>
           </a:xfrm>
           <a:prstGeom prst="rect">
             <a:avLst/>
@@ -3305,13 +3305,13 @@
           <a:p>
             <a:pPr algn="ctr"/>
             <a:r>
-              <a:rPr sz="2400" b="1" i="0" dirty="0">
+              <a:rPr sz="2400" b="1" i="0">
                 <a:solidFill>
                   <a:srgbClr val="FFFFFF"/>
                 </a:solidFill>
                 <a:latin typeface="Calibri"/>
               </a:rPr>
-              <a:t>A k-Nearest Neighbors Classifier</a:t>
+              <a:t>A k-Nearest Neighbors Classifier Built From Scratch</a:t>
             </a:r>
           </a:p>
         </p:txBody>
@@ -3858,7 +3858,7 @@
           <a:p>
             <a:pPr algn="l"/>
             <a:r>
-              <a:rPr sz="1600" b="1" i="0" dirty="0">
+              <a:rPr sz="1600" b="1" i="0">
                 <a:solidFill>
                   <a:srgbClr val="DD8452"/>
                 </a:solidFill>
@@ -3877,7 +3877,7 @@
         </p:nvSpPr>
         <p:spPr>
           <a:xfrm>
-            <a:off x="7772400" y="4983480"/>
+            <a:off x="7726679" y="5212080"/>
             <a:ext cx="3931920" cy="1371600"/>
           </a:xfrm>
           <a:prstGeom prst="rect">
@@ -3900,7 +3900,7 @@
               </a:spcAft>
             </a:pPr>
             <a:r>
-              <a:rPr sz="1300" dirty="0">
+              <a:rPr sz="1300">
                 <a:solidFill>
                   <a:srgbClr val="1A1A1A"/>
                 </a:solidFill>
@@ -3919,7 +3919,7 @@
               </a:spcAft>
             </a:pPr>
             <a:r>
-              <a:rPr sz="1300" dirty="0">
+              <a:rPr sz="1300">
                 <a:solidFill>
                   <a:srgbClr val="1A1A1A"/>
                 </a:solidFill>
@@ -3939,7 +3939,7 @@
         <p:spPr>
           <a:xfrm>
             <a:off x="457200" y="6492240"/>
-            <a:ext cx="7315200" cy="246221"/>
+            <a:ext cx="7315200" cy="274320"/>
           </a:xfrm>
           <a:prstGeom prst="rect">
             <a:avLst/>
@@ -3954,29 +3954,14 @@
           <a:p>
             <a:pPr algn="l"/>
             <a:r>
-              <a:rPr sz="1000" b="0" i="0" dirty="0">
+              <a:rPr sz="1000" b="0" i="0">
                 <a:solidFill>
                   <a:srgbClr val="556070"/>
                 </a:solidFill>
                 <a:latin typeface="Calibri"/>
               </a:rPr>
-              <a:t>Online Shoppers Purchase-Intention Capstone  |  </a:t>
-            </a:r>
-            <a:r>
-              <a:rPr sz="1000" b="0" i="0" dirty="0" err="1">
-                <a:solidFill>
-                  <a:srgbClr val="556070"/>
-                </a:solidFill>
-                <a:latin typeface="Calibri"/>
-              </a:rPr>
-              <a:t>kNN</a:t>
-            </a:r>
-            <a:endParaRPr sz="1000" b="0" i="0" dirty="0">
-              <a:solidFill>
-                <a:srgbClr val="556070"/>
-              </a:solidFill>
-              <a:latin typeface="Calibri"/>
-            </a:endParaRPr>
+              <a:t>Online Shoppers Purchase-Intention Capstone  |  kNN from Scratch</a:t>
+            </a:r>
           </a:p>
         </p:txBody>
       </p:sp>
@@ -4193,7 +4178,7 @@
                 </a:solidFill>
                 <a:latin typeface="Calibri"/>
               </a:rPr>
-              <a:t>k-Nearest Neighbors in One Picture</a:t>
+              <a:t>The Same Idea in Four Steps</a:t>
             </a:r>
           </a:p>
         </p:txBody>
@@ -4391,7 +4376,7 @@
           <a:p>
             <a:pPr algn="ctr"/>
             <a:r>
-              <a:rPr sz="2000" b="1" i="0" dirty="0">
+              <a:rPr sz="2000" b="1" i="0">
                 <a:solidFill>
                   <a:srgbClr val="FFFFFF"/>
                 </a:solidFill>
@@ -5066,7 +5051,7 @@
         <p:spPr>
           <a:xfrm>
             <a:off x="457200" y="6492240"/>
-            <a:ext cx="7315200" cy="246221"/>
+            <a:ext cx="7315200" cy="274320"/>
           </a:xfrm>
           <a:prstGeom prst="rect">
             <a:avLst/>
@@ -5081,29 +5066,14 @@
           <a:p>
             <a:pPr algn="l"/>
             <a:r>
-              <a:rPr sz="1000" b="0" i="0" dirty="0">
+              <a:rPr sz="1000" b="0" i="0">
                 <a:solidFill>
                   <a:srgbClr val="556070"/>
                 </a:solidFill>
                 <a:latin typeface="Calibri"/>
               </a:rPr>
-              <a:t>Online Shoppers Purchase-Intention Capstone  |  </a:t>
-            </a:r>
-            <a:r>
-              <a:rPr sz="1000" b="0" i="0" dirty="0" err="1">
-                <a:solidFill>
-                  <a:srgbClr val="556070"/>
-                </a:solidFill>
-                <a:latin typeface="Calibri"/>
-              </a:rPr>
-              <a:t>kNN</a:t>
-            </a:r>
-            <a:endParaRPr sz="1000" b="0" i="0" dirty="0">
-              <a:solidFill>
-                <a:srgbClr val="556070"/>
-              </a:solidFill>
-              <a:latin typeface="Calibri"/>
-            </a:endParaRPr>
+              <a:t>Online Shoppers Purchase-Intention Capstone  |  kNN from Scratch</a:t>
+            </a:r>
           </a:p>
         </p:txBody>
       </p:sp>
@@ -5137,7 +5107,7 @@
                 </a:solidFill>
                 <a:latin typeface="Calibri"/>
               </a:rPr>
-              <a:t>Slide 11</a:t>
+              <a:t>Slide 12</a:t>
             </a:r>
           </a:p>
         </p:txBody>
@@ -5299,7 +5269,7 @@
         <p:spPr>
           <a:xfrm>
             <a:off x="457200" y="685800"/>
-            <a:ext cx="11247120" cy="553998"/>
+            <a:ext cx="11247120" cy="640080"/>
           </a:xfrm>
           <a:prstGeom prst="rect">
             <a:avLst/>
@@ -5314,31 +5284,13 @@
           <a:p>
             <a:pPr algn="l"/>
             <a:r>
-              <a:rPr sz="3000" b="1" i="0" dirty="0">
+              <a:rPr sz="3000" b="1" i="0">
                 <a:solidFill>
                   <a:srgbClr val="1F3A5F"/>
                 </a:solidFill>
                 <a:latin typeface="Calibri"/>
               </a:rPr>
-              <a:t>The Pipeline We Built — Seven Scripts</a:t>
-            </a:r>
-            <a:r>
-              <a:rPr lang="en-US" sz="3000" b="1" dirty="0">
-                <a:solidFill>
-                  <a:srgbClr val="1F3A5F"/>
-                </a:solidFill>
-                <a:latin typeface="Calibri"/>
-              </a:rPr>
-              <a:t> </a:t>
-            </a:r>
-            <a:r>
-              <a:rPr sz="3000" b="1" i="0" dirty="0">
-                <a:solidFill>
-                  <a:srgbClr val="1F3A5F"/>
-                </a:solidFill>
-                <a:latin typeface="Calibri"/>
-              </a:rPr>
-              <a:t>Estimators</a:t>
+              <a:t>The Pipeline We Built — Seven Scripts, No scikit-learn Estimators</a:t>
             </a:r>
           </a:p>
         </p:txBody>
@@ -5352,7 +5304,7 @@
         <p:spPr>
           <a:xfrm>
             <a:off x="457200" y="1280160"/>
-            <a:ext cx="11247120" cy="323165"/>
+            <a:ext cx="11247120" cy="365760"/>
           </a:xfrm>
           <a:prstGeom prst="rect">
             <a:avLst/>
@@ -5367,31 +5319,13 @@
           <a:p>
             <a:pPr algn="l"/>
             <a:r>
-              <a:rPr sz="1500" b="0" i="1" dirty="0">
+              <a:rPr sz="1500" b="0" i="1">
                 <a:solidFill>
                   <a:srgbClr val="556070"/>
                 </a:solidFill>
                 <a:latin typeface="Calibri"/>
               </a:rPr>
-              <a:t>Every step was implemented from</a:t>
-            </a:r>
-            <a:r>
-              <a:rPr lang="en-US" sz="1500" i="1" dirty="0">
-                <a:solidFill>
-                  <a:srgbClr val="556070"/>
-                </a:solidFill>
-                <a:latin typeface="Calibri"/>
-              </a:rPr>
-              <a:t> </a:t>
-            </a:r>
-            <a:r>
-              <a:rPr sz="1500" b="0" i="1" dirty="0">
-                <a:solidFill>
-                  <a:srgbClr val="556070"/>
-                </a:solidFill>
-                <a:latin typeface="Calibri"/>
-              </a:rPr>
-              <a:t>NumPy to make the algorithm visible.</a:t>
+              <a:t>Every step was implemented from scratch in NumPy to make the algorithm visible.</a:t>
             </a:r>
           </a:p>
         </p:txBody>
@@ -6645,7 +6579,7 @@
         <p:spPr>
           <a:xfrm>
             <a:off x="457200" y="6492240"/>
-            <a:ext cx="7315200" cy="246221"/>
+            <a:ext cx="7315200" cy="274320"/>
           </a:xfrm>
           <a:prstGeom prst="rect">
             <a:avLst/>
@@ -6660,29 +6594,14 @@
           <a:p>
             <a:pPr algn="l"/>
             <a:r>
-              <a:rPr sz="1000" b="0" i="0" dirty="0">
+              <a:rPr sz="1000" b="0" i="0">
                 <a:solidFill>
                   <a:srgbClr val="556070"/>
                 </a:solidFill>
                 <a:latin typeface="Calibri"/>
               </a:rPr>
-              <a:t>Online Shoppers Purchase-Intention Capstone  |  </a:t>
-            </a:r>
-            <a:r>
-              <a:rPr sz="1000" b="0" i="0" dirty="0" err="1">
-                <a:solidFill>
-                  <a:srgbClr val="556070"/>
-                </a:solidFill>
-                <a:latin typeface="Calibri"/>
-              </a:rPr>
-              <a:t>kNN</a:t>
-            </a:r>
-            <a:endParaRPr sz="1000" b="0" i="0" dirty="0">
-              <a:solidFill>
-                <a:srgbClr val="556070"/>
-              </a:solidFill>
-              <a:latin typeface="Calibri"/>
-            </a:endParaRPr>
+              <a:t>Online Shoppers Purchase-Intention Capstone  |  kNN from Scratch</a:t>
+            </a:r>
           </a:p>
         </p:txBody>
       </p:sp>
@@ -6716,7 +6635,7 @@
                 </a:solidFill>
                 <a:latin typeface="Calibri"/>
               </a:rPr>
-              <a:t>Slide 12</a:t>
+              <a:t>Slide 13</a:t>
             </a:r>
           </a:p>
         </p:txBody>
@@ -6913,7 +6832,7 @@
         <p:spPr>
           <a:xfrm>
             <a:off x="457200" y="1280160"/>
-            <a:ext cx="11247120" cy="323165"/>
+            <a:ext cx="11247120" cy="365760"/>
           </a:xfrm>
           <a:prstGeom prst="rect">
             <a:avLst/>
@@ -6928,20 +6847,14 @@
           <a:p>
             <a:pPr algn="l"/>
             <a:r>
-              <a:rPr lang="en-US" sz="1500" b="0" i="1" dirty="0">
+              <a:rPr sz="1500" b="0" i="1">
                 <a:solidFill>
                   <a:srgbClr val="556070"/>
                 </a:solidFill>
                 <a:latin typeface="Calibri"/>
               </a:rPr>
-              <a:t>F1 peaks at k = 3; we chose k = 7 for its higher precision. Recall and precision pull in opposite directions.</a:t>
-            </a:r>
-            <a:endParaRPr sz="1500" b="0" i="1" dirty="0">
-              <a:solidFill>
-                <a:srgbClr val="556070"/>
-              </a:solidFill>
-              <a:latin typeface="Calibri"/>
-            </a:endParaRPr>
+              <a:t>F1 peaks at k = 7. Recall and precision pull in opposite directions.</a:t>
+            </a:r>
           </a:p>
         </p:txBody>
       </p:sp>
@@ -6989,6 +6902,30 @@
           </a:p>
         </p:txBody>
       </p:sp>
+      <p:pic>
+        <p:nvPicPr>
+          <p:cNvPr id="8" name="Picture 7" descr="fig7_k_tuning.png"/>
+          <p:cNvPicPr>
+            <a:picLocks noChangeAspect="1"/>
+          </p:cNvPicPr>
+          <p:nvPr/>
+        </p:nvPicPr>
+        <p:blipFill>
+          <a:blip r:embed="rId2"/>
+          <a:stretch>
+            <a:fillRect/>
+          </a:stretch>
+        </p:blipFill>
+        <p:spPr>
+          <a:xfrm>
+            <a:off x="365760" y="1920240"/>
+            <a:ext cx="7315200" cy="3948596"/>
+          </a:xfrm>
+          <a:prstGeom prst="rect">
+            <a:avLst/>
+          </a:prstGeom>
+        </p:spPr>
+      </p:pic>
       <p:sp>
         <p:nvSpPr>
           <p:cNvPr id="9" name="Rounded Rectangle 8"/>
@@ -7079,8 +7016,8 @@
         </p:nvSpPr>
         <p:spPr>
           <a:xfrm>
-            <a:off x="8046720" y="2614832"/>
-            <a:ext cx="3566160" cy="1536896"/>
+            <a:off x="8092440" y="2606040"/>
+            <a:ext cx="3566160" cy="2377440"/>
           </a:xfrm>
           <a:prstGeom prst="rect">
             <a:avLst/>
@@ -7102,7 +7039,7 @@
               </a:spcAft>
             </a:pPr>
             <a:r>
-              <a:rPr sz="1300" dirty="0">
+              <a:rPr sz="1300">
                 <a:solidFill>
                   <a:srgbClr val="1A1A1A"/>
                 </a:solidFill>
@@ -7121,7 +7058,7 @@
               </a:spcAft>
             </a:pPr>
             <a:r>
-              <a:rPr sz="1300" dirty="0">
+              <a:rPr sz="1300">
                 <a:solidFill>
                   <a:srgbClr val="1A1A1A"/>
                 </a:solidFill>
@@ -7140,7 +7077,7 @@
               </a:spcAft>
             </a:pPr>
             <a:r>
-              <a:rPr sz="1300" dirty="0">
+              <a:rPr sz="1300">
                 <a:solidFill>
                   <a:srgbClr val="1A1A1A"/>
                 </a:solidFill>
@@ -7159,30 +7096,73 @@
               </a:spcAft>
             </a:pPr>
             <a:r>
-              <a:rPr sz="1300" dirty="0">
+              <a:rPr sz="1300">
                 <a:solidFill>
                   <a:srgbClr val="1A1A1A"/>
                 </a:solidFill>
                 <a:latin typeface="Calibri"/>
               </a:rPr>
-              <a:t>•  Best F1:         k = </a:t>
-            </a:r>
-            <a:r>
-              <a:rPr lang="en-PH" sz="1300" dirty="0">
-                <a:solidFill>
-                  <a:srgbClr val="1A1A1A"/>
-                </a:solidFill>
-                <a:latin typeface="Calibri"/>
-              </a:rPr>
-              <a:t>3</a:t>
-            </a:r>
-            <a:endParaRPr lang="en-US" sz="1300" dirty="0">
-              <a:solidFill>
-                <a:srgbClr val="1A1A1A"/>
-              </a:solidFill>
-              <a:latin typeface="Calibri"/>
-            </a:endParaRPr>
-          </a:p>
+              <a:t>•  Best F1:         k = 7  ← chosen</a:t>
+            </a:r>
+          </a:p>
+        </p:txBody>
+      </p:sp>
+      <p:sp>
+        <p:nvSpPr>
+          <p:cNvPr id="12" name="TextBox 11"/>
+          <p:cNvSpPr txBox="1"/>
+          <p:nvPr/>
+        </p:nvSpPr>
+        <p:spPr>
+          <a:xfrm>
+            <a:off x="8092440" y="4572000"/>
+            <a:ext cx="3566160" cy="457200"/>
+          </a:xfrm>
+          <a:prstGeom prst="rect">
+            <a:avLst/>
+          </a:prstGeom>
+          <a:noFill/>
+        </p:spPr>
+        <p:txBody>
+          <a:bodyPr wrap="square" anchor="t">
+            <a:spAutoFit/>
+          </a:bodyPr>
+          <a:lstStyle/>
+          <a:p>
+            <a:pPr algn="l"/>
+            <a:r>
+              <a:rPr sz="1600" b="1" i="0">
+                <a:solidFill>
+                  <a:srgbClr val="DD8452"/>
+                </a:solidFill>
+                <a:latin typeface="Calibri"/>
+              </a:rPr>
+              <a:t>Why F1?</a:t>
+            </a:r>
+          </a:p>
+        </p:txBody>
+      </p:sp>
+      <p:sp>
+        <p:nvSpPr>
+          <p:cNvPr id="13" name="TextBox 12"/>
+          <p:cNvSpPr txBox="1"/>
+          <p:nvPr/>
+        </p:nvSpPr>
+        <p:spPr>
+          <a:xfrm>
+            <a:off x="8092440" y="5029200"/>
+            <a:ext cx="3566160" cy="1371600"/>
+          </a:xfrm>
+          <a:prstGeom prst="rect">
+            <a:avLst/>
+          </a:prstGeom>
+          <a:noFill/>
+        </p:spPr>
+        <p:txBody>
+          <a:bodyPr wrap="square">
+            <a:spAutoFit/>
+          </a:bodyPr>
+          <a:lstStyle/>
           <a:p>
             <a:pPr algn="l">
               <a:lnSpc>
@@ -7193,85 +7173,15 @@
               </a:spcAft>
             </a:pPr>
             <a:r>
-              <a:rPr lang="en-US" sz="1300" dirty="0">
+              <a:rPr sz="1200">
                 <a:solidFill>
                   <a:srgbClr val="1A1A1A"/>
                 </a:solidFill>
                 <a:latin typeface="Calibri"/>
               </a:rPr>
-              <a:t>Chosen:             k = 7 (higher precision)</a:t>
-            </a:r>
-            <a:endParaRPr sz="1300" dirty="0">
-              <a:solidFill>
-                <a:srgbClr val="1A1A1A"/>
-              </a:solidFill>
-              <a:latin typeface="Calibri"/>
-            </a:endParaRPr>
-          </a:p>
-        </p:txBody>
-      </p:sp>
-      <p:sp>
-        <p:nvSpPr>
-          <p:cNvPr id="12" name="TextBox 11"/>
-          <p:cNvSpPr txBox="1"/>
-          <p:nvPr/>
-        </p:nvSpPr>
-        <p:spPr>
-          <a:xfrm>
-            <a:off x="8092440" y="4572000"/>
-            <a:ext cx="3566160" cy="338554"/>
-          </a:xfrm>
-          <a:prstGeom prst="rect">
-            <a:avLst/>
-          </a:prstGeom>
-          <a:noFill/>
-        </p:spPr>
-        <p:txBody>
-          <a:bodyPr wrap="square" anchor="t">
-            <a:spAutoFit/>
-          </a:bodyPr>
-          <a:lstStyle/>
-          <a:p>
-            <a:pPr algn="l"/>
-            <a:r>
-              <a:rPr lang="en-PH" sz="1600" b="1" i="0" dirty="0">
-                <a:solidFill>
-                  <a:srgbClr val="DD8452"/>
-                </a:solidFill>
-                <a:latin typeface="Calibri"/>
-              </a:rPr>
-              <a:t>How we chose k</a:t>
-            </a:r>
-            <a:endParaRPr sz="1600" b="1" i="0" dirty="0">
-              <a:solidFill>
-                <a:srgbClr val="DD8452"/>
-              </a:solidFill>
-              <a:latin typeface="Calibri"/>
-            </a:endParaRPr>
-          </a:p>
-        </p:txBody>
-      </p:sp>
-      <p:sp>
-        <p:nvSpPr>
-          <p:cNvPr id="13" name="TextBox 12"/>
-          <p:cNvSpPr txBox="1"/>
-          <p:nvPr/>
-        </p:nvSpPr>
-        <p:spPr>
-          <a:xfrm>
-            <a:off x="8092440" y="5029200"/>
-            <a:ext cx="3566160" cy="1006301"/>
-          </a:xfrm>
-          <a:prstGeom prst="rect">
-            <a:avLst/>
-          </a:prstGeom>
-          <a:noFill/>
-        </p:spPr>
-        <p:txBody>
-          <a:bodyPr wrap="square">
-            <a:spAutoFit/>
-          </a:bodyPr>
-          <a:lstStyle/>
+              <a:t>•  Balances precision and recall.</a:t>
+            </a:r>
+          </a:p>
           <a:p>
             <a:pPr algn="l">
               <a:lnSpc>
@@ -7282,57 +7192,14 @@
               </a:spcAft>
             </a:pPr>
             <a:r>
-              <a:rPr sz="1200" dirty="0">
+              <a:rPr sz="1200">
                 <a:solidFill>
                   <a:srgbClr val="1A1A1A"/>
                 </a:solidFill>
                 <a:latin typeface="Calibri"/>
               </a:rPr>
-              <a:t>•  </a:t>
-            </a:r>
-            <a:r>
-              <a:rPr lang="en-US" sz="1200" dirty="0">
-                <a:solidFill>
-                  <a:srgbClr val="1A1A1A"/>
-                </a:solidFill>
-                <a:latin typeface="Calibri"/>
-              </a:rPr>
-              <a:t>F1 to find the peak region (k ≈ 3–9), avoiding both extremes.</a:t>
-            </a:r>
-          </a:p>
-          <a:p>
-            <a:pPr algn="l">
-              <a:lnSpc>
-                <a:spcPct val="115000"/>
-              </a:lnSpc>
-              <a:spcAft>
-                <a:spcPts val="600"/>
-              </a:spcAft>
-            </a:pPr>
-            <a:r>
-              <a:rPr sz="1200" dirty="0">
-                <a:solidFill>
-                  <a:srgbClr val="1A1A1A"/>
-                </a:solidFill>
-                <a:latin typeface="Calibri"/>
-              </a:rPr>
-              <a:t>•  </a:t>
-            </a:r>
-            <a:r>
-              <a:rPr lang="en-US" sz="1200" dirty="0">
-                <a:solidFill>
-                  <a:srgbClr val="1A1A1A"/>
-                </a:solidFill>
-                <a:latin typeface="Calibri"/>
-              </a:rPr>
-              <a:t>Precision to pick within it → k = 7 — a confident, conservative classifier.</a:t>
-            </a:r>
-            <a:endParaRPr sz="1200" dirty="0">
-              <a:solidFill>
-                <a:srgbClr val="1A1A1A"/>
-              </a:solidFill>
-              <a:latin typeface="Calibri"/>
-            </a:endParaRPr>
+              <a:t>•  The right metric when both false positives and false negatives matter.</a:t>
+            </a:r>
           </a:p>
         </p:txBody>
       </p:sp>
@@ -7345,7 +7212,7 @@
         <p:spPr>
           <a:xfrm>
             <a:off x="457200" y="6492240"/>
-            <a:ext cx="7315200" cy="246221"/>
+            <a:ext cx="7315200" cy="274320"/>
           </a:xfrm>
           <a:prstGeom prst="rect">
             <a:avLst/>
@@ -7360,38 +7227,14 @@
           <a:p>
             <a:pPr algn="l"/>
             <a:r>
-              <a:rPr sz="1000" b="0" i="0" dirty="0">
+              <a:rPr sz="1000" b="0" i="0">
                 <a:solidFill>
                   <a:srgbClr val="556070"/>
                 </a:solidFill>
                 <a:latin typeface="Calibri"/>
               </a:rPr>
-              <a:t>Online Shoppers Purchase-Intention Capstone  |  </a:t>
-            </a:r>
-            <a:r>
-              <a:rPr sz="1000" b="0" i="0" dirty="0" err="1">
-                <a:solidFill>
-                  <a:srgbClr val="556070"/>
-                </a:solidFill>
-                <a:latin typeface="Calibri"/>
-              </a:rPr>
-              <a:t>kN</a:t>
-            </a:r>
-            <a:r>
-              <a:rPr lang="en-US" sz="1000" b="0" i="0" dirty="0" err="1">
-                <a:solidFill>
-                  <a:srgbClr val="556070"/>
-                </a:solidFill>
-                <a:latin typeface="Calibri"/>
-              </a:rPr>
-              <a:t>N</a:t>
-            </a:r>
-            <a:endParaRPr sz="1000" b="0" i="0" dirty="0">
-              <a:solidFill>
-                <a:srgbClr val="556070"/>
-              </a:solidFill>
-              <a:latin typeface="Calibri"/>
-            </a:endParaRPr>
+              <a:t>Online Shoppers Purchase-Intention Capstone  |  kNN from Scratch</a:t>
+            </a:r>
           </a:p>
         </p:txBody>
       </p:sp>
@@ -7425,41 +7268,11 @@
                 </a:solidFill>
                 <a:latin typeface="Calibri"/>
               </a:rPr>
-              <a:t>Slide 13</a:t>
-            </a:r>
-          </a:p>
-        </p:txBody>
-      </p:sp>
-      <p:pic>
-        <p:nvPicPr>
-          <p:cNvPr id="17" name="Picture 16">
-            <a:extLst>
-              <a:ext uri="{FF2B5EF4-FFF2-40B4-BE49-F238E27FC236}">
-                <a16:creationId xmlns:a16="http://schemas.microsoft.com/office/drawing/2014/main" id="{F1B267E2-0090-66C2-4F43-9A070DDC2241}"/>
-              </a:ext>
-            </a:extLst>
-          </p:cNvPr>
-          <p:cNvPicPr>
-            <a:picLocks noChangeAspect="1"/>
-          </p:cNvPicPr>
-          <p:nvPr/>
-        </p:nvPicPr>
-        <p:blipFill>
-          <a:blip r:embed="rId2"/>
-          <a:stretch>
-            <a:fillRect/>
-          </a:stretch>
-        </p:blipFill>
-        <p:spPr>
-          <a:xfrm>
-            <a:off x="457200" y="1904729"/>
-            <a:ext cx="7315200" cy="3948596"/>
-          </a:xfrm>
-          <a:prstGeom prst="rect">
-            <a:avLst/>
-          </a:prstGeom>
-        </p:spPr>
-      </p:pic>
+              <a:t>Slide 14</a:t>
+            </a:r>
+          </a:p>
+        </p:txBody>
+      </p:sp>
     </p:spTree>
   </p:cSld>
   <p:clrMapOvr>
@@ -8542,7 +8355,7 @@
         <p:spPr>
           <a:xfrm>
             <a:off x="457200" y="6492240"/>
-            <a:ext cx="7315200" cy="246221"/>
+            <a:ext cx="7315200" cy="274320"/>
           </a:xfrm>
           <a:prstGeom prst="rect">
             <a:avLst/>
@@ -8557,29 +8370,14 @@
           <a:p>
             <a:pPr algn="l"/>
             <a:r>
-              <a:rPr sz="1000" b="0" i="0" dirty="0">
+              <a:rPr sz="1000" b="0" i="0">
                 <a:solidFill>
                   <a:srgbClr val="556070"/>
                 </a:solidFill>
                 <a:latin typeface="Calibri"/>
               </a:rPr>
-              <a:t>Online Shoppers Purchase-Intention Capstone  |  </a:t>
-            </a:r>
-            <a:r>
-              <a:rPr sz="1000" b="0" i="0" dirty="0" err="1">
-                <a:solidFill>
-                  <a:srgbClr val="556070"/>
-                </a:solidFill>
-                <a:latin typeface="Calibri"/>
-              </a:rPr>
-              <a:t>kNN</a:t>
-            </a:r>
-            <a:endParaRPr sz="1000" b="0" i="0" dirty="0">
-              <a:solidFill>
-                <a:srgbClr val="556070"/>
-              </a:solidFill>
-              <a:latin typeface="Calibri"/>
-            </a:endParaRPr>
+              <a:t>Online Shoppers Purchase-Intention Capstone  |  kNN from Scratch</a:t>
+            </a:r>
           </a:p>
         </p:txBody>
       </p:sp>
@@ -8613,7 +8411,7 @@
                 </a:solidFill>
                 <a:latin typeface="Calibri"/>
               </a:rPr>
-              <a:t>Slide 14</a:t>
+              <a:t>Slide 15</a:t>
             </a:r>
           </a:p>
         </p:txBody>
@@ -8882,7 +8680,7 @@
       </p:sp>
       <p:pic>
         <p:nvPicPr>
-          <p:cNvPr id="8" name="Picture 7"/>
+          <p:cNvPr id="8" name="Picture 7" descr="fig8_final_confusion_matrix.png"/>
           <p:cNvPicPr>
             <a:picLocks noChangeAspect="1"/>
           </p:cNvPicPr>
@@ -8890,13 +8688,14 @@
         </p:nvPicPr>
         <p:blipFill>
           <a:blip r:embed="rId2"/>
-          <a:srcRect/>
-          <a:stretch/>
+          <a:stretch>
+            <a:fillRect/>
+          </a:stretch>
         </p:blipFill>
         <p:spPr>
           <a:xfrm>
             <a:off x="365760" y="1920240"/>
-            <a:ext cx="8229599" cy="2886678"/>
+            <a:ext cx="8229600" cy="2886678"/>
           </a:xfrm>
           <a:prstGeom prst="rect">
             <a:avLst/>
@@ -9074,7 +8873,7 @@
         <p:spPr>
           <a:xfrm>
             <a:off x="457200" y="6492240"/>
-            <a:ext cx="7315200" cy="246221"/>
+            <a:ext cx="7315200" cy="274320"/>
           </a:xfrm>
           <a:prstGeom prst="rect">
             <a:avLst/>
@@ -9089,29 +8888,14 @@
           <a:p>
             <a:pPr algn="l"/>
             <a:r>
-              <a:rPr sz="1000" b="0" i="0" dirty="0">
+              <a:rPr sz="1000" b="0" i="0">
                 <a:solidFill>
                   <a:srgbClr val="556070"/>
                 </a:solidFill>
                 <a:latin typeface="Calibri"/>
               </a:rPr>
-              <a:t>Online Shoppers Purchase-Intention Capstone  |  </a:t>
-            </a:r>
-            <a:r>
-              <a:rPr sz="1000" b="0" i="0" dirty="0" err="1">
-                <a:solidFill>
-                  <a:srgbClr val="556070"/>
-                </a:solidFill>
-                <a:latin typeface="Calibri"/>
-              </a:rPr>
-              <a:t>kNN</a:t>
-            </a:r>
-            <a:endParaRPr sz="1000" b="0" i="0" dirty="0">
-              <a:solidFill>
-                <a:srgbClr val="556070"/>
-              </a:solidFill>
-              <a:latin typeface="Calibri"/>
-            </a:endParaRPr>
+              <a:t>Online Shoppers Purchase-Intention Capstone  |  kNN from Scratch</a:t>
+            </a:r>
           </a:p>
         </p:txBody>
       </p:sp>
@@ -9145,7 +8929,7 @@
                 </a:solidFill>
                 <a:latin typeface="Calibri"/>
               </a:rPr>
-              <a:t>Slide 15</a:t>
+              <a:t>Slide 16</a:t>
             </a:r>
           </a:p>
         </p:txBody>
@@ -9307,7 +9091,7 @@
         <p:spPr>
           <a:xfrm>
             <a:off x="457200" y="685800"/>
-            <a:ext cx="11247120" cy="553998"/>
+            <a:ext cx="11247120" cy="640080"/>
           </a:xfrm>
           <a:prstGeom prst="rect">
             <a:avLst/>
@@ -9322,20 +9106,14 @@
           <a:p>
             <a:pPr algn="l"/>
             <a:r>
-              <a:rPr lang="en-US" sz="3000" b="1" i="0" dirty="0">
+              <a:rPr sz="3000" b="1" i="0">
                 <a:solidFill>
                   <a:srgbClr val="1F3A5F"/>
                 </a:solidFill>
                 <a:latin typeface="Calibri"/>
               </a:rPr>
-              <a:t>Validation: Stable Across Folds — but a Simple Rule Beats Us</a:t>
-            </a:r>
-            <a:endParaRPr sz="3000" b="1" i="0" dirty="0">
-              <a:solidFill>
-                <a:srgbClr val="1F3A5F"/>
-              </a:solidFill>
-              <a:latin typeface="Calibri"/>
-            </a:endParaRPr>
+              <a:t>Validation: Stable Across Folds, and Beats the Baselines</a:t>
+            </a:r>
           </a:p>
         </p:txBody>
       </p:sp>
@@ -9348,7 +9126,7 @@
         <p:spPr>
           <a:xfrm>
             <a:off x="457200" y="1280160"/>
-            <a:ext cx="11247120" cy="323165"/>
+            <a:ext cx="11247120" cy="365760"/>
           </a:xfrm>
           <a:prstGeom prst="rect">
             <a:avLst/>
@@ -9363,56 +9141,14 @@
           <a:p>
             <a:pPr algn="l"/>
             <a:r>
-              <a:rPr lang="en-US" sz="1500" b="0" i="1" dirty="0">
+              <a:rPr sz="1500" b="0" i="1">
                 <a:solidFill>
                   <a:srgbClr val="556070"/>
                 </a:solidFill>
                 <a:latin typeface="Calibri"/>
               </a:rPr>
-              <a:t>5-fold stratified CV confirms stability; but a one-feature </a:t>
-            </a:r>
-            <a:r>
-              <a:rPr lang="en-US" sz="1500" b="0" i="1" dirty="0" err="1">
-                <a:solidFill>
-                  <a:srgbClr val="556070"/>
-                </a:solidFill>
-                <a:latin typeface="Calibri"/>
-              </a:rPr>
-              <a:t>PageValues</a:t>
-            </a:r>
-            <a:r>
-              <a:rPr lang="en-US" sz="1500" b="0" i="1" dirty="0">
-                <a:solidFill>
-                  <a:srgbClr val="556070"/>
-                </a:solidFill>
-                <a:latin typeface="Calibri"/>
-              </a:rPr>
-              <a:t> rule outperforms our </a:t>
-            </a:r>
-            <a:r>
-              <a:rPr lang="en-US" sz="1500" b="0" i="1" dirty="0" err="1">
-                <a:solidFill>
-                  <a:srgbClr val="556070"/>
-                </a:solidFill>
-                <a:latin typeface="Calibri"/>
-              </a:rPr>
-              <a:t>kNN</a:t>
-            </a:r>
-            <a:r>
-              <a:rPr lang="en-US" sz="1500" b="0" i="1" dirty="0">
-                <a:solidFill>
-                  <a:srgbClr val="556070"/>
-                </a:solidFill>
-                <a:latin typeface="Calibri"/>
-              </a:rPr>
-              <a:t>.</a:t>
-            </a:r>
-            <a:endParaRPr sz="1500" b="0" i="1" dirty="0">
-              <a:solidFill>
-                <a:srgbClr val="556070"/>
-              </a:solidFill>
-              <a:latin typeface="Calibri"/>
-            </a:endParaRPr>
+              <a:t>5-fold stratified CV plus two principled baselines confirm the result is real.</a:t>
+            </a:r>
           </a:p>
         </p:txBody>
       </p:sp>
@@ -9573,7 +9309,7 @@
               </a:spcAft>
             </a:pPr>
             <a:r>
-              <a:rPr sz="1300" dirty="0">
+              <a:rPr sz="1300">
                 <a:solidFill>
                   <a:srgbClr val="1A1A1A"/>
                 </a:solidFill>
@@ -9592,7 +9328,7 @@
               </a:spcAft>
             </a:pPr>
             <a:r>
-              <a:rPr sz="1300" dirty="0">
+              <a:rPr sz="1300">
                 <a:solidFill>
                   <a:srgbClr val="1A1A1A"/>
                 </a:solidFill>
@@ -9611,7 +9347,7 @@
               </a:spcAft>
             </a:pPr>
             <a:r>
-              <a:rPr sz="1300" dirty="0">
+              <a:rPr sz="1300">
                 <a:solidFill>
                   <a:srgbClr val="1A1A1A"/>
                 </a:solidFill>
@@ -9630,7 +9366,7 @@
               </a:spcAft>
             </a:pPr>
             <a:r>
-              <a:rPr sz="1300" dirty="0">
+              <a:rPr sz="1300">
                 <a:solidFill>
                   <a:srgbClr val="1A1A1A"/>
                 </a:solidFill>
@@ -10290,7 +10026,7 @@
         <p:spPr>
           <a:xfrm>
             <a:off x="6400800" y="4754880"/>
-            <a:ext cx="5212080" cy="646331"/>
+            <a:ext cx="5212080" cy="1280160"/>
           </a:xfrm>
           <a:prstGeom prst="rect">
             <a:avLst/>
@@ -10305,133 +10041,49 @@
           <a:p>
             <a:pPr algn="l"/>
             <a:r>
-              <a:rPr lang="en-US" sz="1200" b="0" i="1" dirty="0" err="1">
+              <a:rPr sz="1200" b="0" i="1">
                 <a:solidFill>
                   <a:srgbClr val="556070"/>
                 </a:solidFill>
                 <a:latin typeface="Calibri"/>
               </a:rPr>
-              <a:t>kNN</a:t>
-            </a:r>
-            <a:r>
-              <a:rPr lang="en-US" sz="1200" b="0" i="1" dirty="0">
+              <a:t>kNN beats both baselines on F1 — a real signal, not memorization of one dominant feature.</a:t>
+            </a:r>
+          </a:p>
+        </p:txBody>
+      </p:sp>
+      <p:sp>
+        <p:nvSpPr>
+          <p:cNvPr id="29" name="TextBox 28"/>
+          <p:cNvSpPr txBox="1"/>
+          <p:nvPr/>
+        </p:nvSpPr>
+        <p:spPr>
+          <a:xfrm>
+            <a:off x="457200" y="6492240"/>
+            <a:ext cx="7315200" cy="274320"/>
+          </a:xfrm>
+          <a:prstGeom prst="rect">
+            <a:avLst/>
+          </a:prstGeom>
+          <a:noFill/>
+        </p:spPr>
+        <p:txBody>
+          <a:bodyPr wrap="square" anchor="t">
+            <a:spAutoFit/>
+          </a:bodyPr>
+          <a:lstStyle/>
+          <a:p>
+            <a:pPr algn="l"/>
+            <a:r>
+              <a:rPr sz="1000" b="0" i="0">
                 <a:solidFill>
                   <a:srgbClr val="556070"/>
                 </a:solidFill>
                 <a:latin typeface="Calibri"/>
               </a:rPr>
-              <a:t> beats both baselines on F1 — a real signal… → The </a:t>
-            </a:r>
-            <a:r>
-              <a:rPr lang="en-US" sz="1200" b="0" i="1" dirty="0" err="1">
-                <a:solidFill>
-                  <a:srgbClr val="556070"/>
-                </a:solidFill>
-                <a:latin typeface="Calibri"/>
-              </a:rPr>
-              <a:t>PageValues</a:t>
-            </a:r>
-            <a:r>
-              <a:rPr lang="en-US" sz="1200" b="0" i="1" dirty="0">
-                <a:solidFill>
-                  <a:srgbClr val="556070"/>
-                </a:solidFill>
-                <a:latin typeface="Calibri"/>
-              </a:rPr>
-              <a:t> rule beats </a:t>
-            </a:r>
-            <a:r>
-              <a:rPr lang="en-US" sz="1200" b="0" i="1" dirty="0" err="1">
-                <a:solidFill>
-                  <a:srgbClr val="556070"/>
-                </a:solidFill>
-                <a:latin typeface="Calibri"/>
-              </a:rPr>
-              <a:t>kNN</a:t>
-            </a:r>
-            <a:r>
-              <a:rPr lang="en-US" sz="1200" b="0" i="1" dirty="0">
-                <a:solidFill>
-                  <a:srgbClr val="556070"/>
-                </a:solidFill>
-                <a:latin typeface="Calibri"/>
-              </a:rPr>
-              <a:t> on F1 — </a:t>
-            </a:r>
-            <a:r>
-              <a:rPr lang="en-US" sz="1200" b="0" i="1" dirty="0" err="1">
-                <a:solidFill>
-                  <a:srgbClr val="556070"/>
-                </a:solidFill>
-                <a:latin typeface="Calibri"/>
-              </a:rPr>
-              <a:t>kNN</a:t>
-            </a:r>
-            <a:r>
-              <a:rPr lang="en-US" sz="1200" b="0" i="1" dirty="0">
-                <a:solidFill>
-                  <a:srgbClr val="556070"/>
-                </a:solidFill>
-                <a:latin typeface="Calibri"/>
-              </a:rPr>
-              <a:t> dilutes the dominant signal across 28 features. A humbling, instructive result.</a:t>
-            </a:r>
-            <a:endParaRPr sz="1200" b="0" i="1" dirty="0">
-              <a:solidFill>
-                <a:srgbClr val="556070"/>
-              </a:solidFill>
-              <a:latin typeface="Calibri"/>
-            </a:endParaRPr>
-          </a:p>
-        </p:txBody>
-      </p:sp>
-      <p:sp>
-        <p:nvSpPr>
-          <p:cNvPr id="29" name="TextBox 28"/>
-          <p:cNvSpPr txBox="1"/>
-          <p:nvPr/>
-        </p:nvSpPr>
-        <p:spPr>
-          <a:xfrm>
-            <a:off x="457200" y="6492240"/>
-            <a:ext cx="7315200" cy="246221"/>
-          </a:xfrm>
-          <a:prstGeom prst="rect">
-            <a:avLst/>
-          </a:prstGeom>
-          <a:noFill/>
-        </p:spPr>
-        <p:txBody>
-          <a:bodyPr wrap="square" anchor="t">
-            <a:spAutoFit/>
-          </a:bodyPr>
-          <a:lstStyle/>
-          <a:p>
-            <a:pPr algn="l"/>
-            <a:r>
-              <a:rPr sz="1000" b="0" i="0" dirty="0">
-                <a:solidFill>
-                  <a:srgbClr val="556070"/>
-                </a:solidFill>
-                <a:latin typeface="Calibri"/>
-              </a:rPr>
-              <a:t>Online Shoppers Purchase-Intention Capstone  |  </a:t>
-            </a:r>
-            <a:r>
-              <a:rPr sz="1000" b="0" i="0" dirty="0" err="1">
-                <a:solidFill>
-                  <a:srgbClr val="556070"/>
-                </a:solidFill>
-                <a:latin typeface="Calibri"/>
-              </a:rPr>
-              <a:t>kNN</a:t>
-            </a:r>
-            <a:endParaRPr sz="1000" b="0" i="0" dirty="0">
-              <a:solidFill>
-                <a:srgbClr val="556070"/>
-              </a:solidFill>
-              <a:latin typeface="Calibri"/>
-            </a:endParaRPr>
+              <a:t>Online Shoppers Purchase-Intention Capstone  |  kNN from Scratch</a:t>
+            </a:r>
           </a:p>
         </p:txBody>
       </p:sp>
@@ -10465,7 +10117,7 @@
                 </a:solidFill>
                 <a:latin typeface="Calibri"/>
               </a:rPr>
-              <a:t>Slide 16</a:t>
+              <a:t>Slide 17</a:t>
             </a:r>
           </a:p>
         </p:txBody>
@@ -11065,7 +10717,7 @@
         <p:spPr>
           <a:xfrm>
             <a:off x="457200" y="6492240"/>
-            <a:ext cx="7315200" cy="246221"/>
+            <a:ext cx="7315200" cy="274320"/>
           </a:xfrm>
           <a:prstGeom prst="rect">
             <a:avLst/>
@@ -11080,29 +10732,14 @@
           <a:p>
             <a:pPr algn="l"/>
             <a:r>
-              <a:rPr sz="1000" b="0" i="0" dirty="0">
+              <a:rPr sz="1000" b="0" i="0">
                 <a:solidFill>
                   <a:srgbClr val="556070"/>
                 </a:solidFill>
                 <a:latin typeface="Calibri"/>
               </a:rPr>
-              <a:t>Online Shoppers Purchase-Intention Capstone  |  </a:t>
-            </a:r>
-            <a:r>
-              <a:rPr sz="1000" b="0" i="0" dirty="0" err="1">
-                <a:solidFill>
-                  <a:srgbClr val="556070"/>
-                </a:solidFill>
-                <a:latin typeface="Calibri"/>
-              </a:rPr>
-              <a:t>kNN</a:t>
-            </a:r>
-            <a:endParaRPr sz="1000" b="0" i="0" dirty="0">
-              <a:solidFill>
-                <a:srgbClr val="556070"/>
-              </a:solidFill>
-              <a:latin typeface="Calibri"/>
-            </a:endParaRPr>
+              <a:t>Online Shoppers Purchase-Intention Capstone  |  kNN from Scratch</a:t>
+            </a:r>
           </a:p>
         </p:txBody>
       </p:sp>
@@ -11136,7 +10773,7 @@
                 </a:solidFill>
                 <a:latin typeface="Calibri"/>
               </a:rPr>
-              <a:t>Slide 17</a:t>
+              <a:t>Slide 18</a:t>
             </a:r>
           </a:p>
         </p:txBody>
@@ -11348,7 +10985,7 @@
           <a:p>
             <a:pPr algn="l"/>
             <a:r>
-              <a:rPr sz="1500" b="0" i="1" dirty="0">
+              <a:rPr sz="1500" b="0" i="1">
                 <a:solidFill>
                   <a:srgbClr val="556070"/>
                 </a:solidFill>
@@ -11506,7 +11143,7 @@
           <a:p>
             <a:pPr algn="l"/>
             <a:r>
-              <a:rPr sz="1200" b="0" i="0" dirty="0">
+              <a:rPr sz="1200" b="0" i="0">
                 <a:solidFill>
                   <a:srgbClr val="1A1A1A"/>
                 </a:solidFill>
@@ -11734,7 +11371,7 @@
           <a:p>
             <a:pPr algn="l"/>
             <a:r>
-              <a:rPr sz="1200" b="0" i="0" dirty="0">
+              <a:rPr sz="1200" b="0" i="0">
                 <a:solidFill>
                   <a:srgbClr val="1A1A1A"/>
                 </a:solidFill>
@@ -11797,8 +11434,8 @@
         </p:nvSpPr>
         <p:spPr>
           <a:xfrm>
-            <a:off x="731520" y="4148697"/>
-            <a:ext cx="3108960" cy="553998"/>
+            <a:off x="731520" y="4105656"/>
+            <a:ext cx="3108960" cy="640080"/>
           </a:xfrm>
           <a:prstGeom prst="rect">
             <a:avLst/>
@@ -11813,38 +11450,14 @@
           <a:p>
             <a:pPr algn="l"/>
             <a:r>
-              <a:rPr lang="en-US" sz="1500" b="1" i="0" dirty="0">
+              <a:rPr sz="1500" b="1" i="0">
                 <a:solidFill>
                   <a:srgbClr val="1F3A5F"/>
                 </a:solidFill>
                 <a:latin typeface="Calibri"/>
               </a:rPr>
-              <a:t>A one-feature </a:t>
-            </a:r>
-            <a:r>
-              <a:rPr lang="en-US" sz="1500" b="1" i="0" dirty="0" err="1">
-                <a:solidFill>
-                  <a:srgbClr val="1F3A5F"/>
-                </a:solidFill>
-                <a:latin typeface="Calibri"/>
-              </a:rPr>
-              <a:t>PageValues</a:t>
-            </a:r>
-            <a:r>
-              <a:rPr lang="en-US" sz="1500" b="1" i="0" dirty="0">
-                <a:solidFill>
-                  <a:srgbClr val="1F3A5F"/>
-                </a:solidFill>
-                <a:latin typeface="Calibri"/>
-              </a:rPr>
-              <a:t> rule beats the full model </a:t>
-            </a:r>
-            <a:endParaRPr sz="1500" b="1" i="0" dirty="0">
-              <a:solidFill>
-                <a:srgbClr val="1F3A5F"/>
-              </a:solidFill>
-              <a:latin typeface="Calibri"/>
-            </a:endParaRPr>
+              <a:t>k tuned on the test set</a:t>
+            </a:r>
           </a:p>
         </p:txBody>
       </p:sp>
@@ -11856,8 +11469,8 @@
         </p:nvSpPr>
         <p:spPr>
           <a:xfrm>
-            <a:off x="3931920" y="4287196"/>
-            <a:ext cx="7772400" cy="276999"/>
+            <a:off x="3931920" y="4105656"/>
+            <a:ext cx="7772400" cy="640080"/>
           </a:xfrm>
           <a:prstGeom prst="rect">
             <a:avLst/>
@@ -11872,29 +11485,14 @@
           <a:p>
             <a:pPr algn="l"/>
             <a:r>
-              <a:rPr lang="en-US" sz="1200" b="0" i="0" dirty="0" err="1">
+              <a:rPr sz="1200" b="0" i="0">
                 <a:solidFill>
                   <a:srgbClr val="1A1A1A"/>
                 </a:solidFill>
                 <a:latin typeface="Calibri"/>
               </a:rPr>
-              <a:t>kNN</a:t>
-            </a:r>
-            <a:r>
-              <a:rPr lang="en-US" sz="1200" b="0" i="0" dirty="0">
-                <a:solidFill>
-                  <a:srgbClr val="1A1A1A"/>
-                </a:solidFill>
-                <a:latin typeface="Calibri"/>
-              </a:rPr>
-              <a:t> doesn't do feature selection.</a:t>
-            </a:r>
-            <a:endParaRPr sz="1200" b="0" i="0" dirty="0">
-              <a:solidFill>
-                <a:srgbClr val="1A1A1A"/>
-              </a:solidFill>
-              <a:latin typeface="Calibri"/>
-            </a:endParaRPr>
+              <a:t>Best F1 was selected directly on the test set. A clean protocol would use a separate validation split. CV partially mitigates this.</a:t>
+            </a:r>
           </a:p>
         </p:txBody>
       </p:sp>
@@ -12135,7 +11733,7 @@
         <p:spPr>
           <a:xfrm>
             <a:off x="457200" y="6492240"/>
-            <a:ext cx="7315200" cy="246221"/>
+            <a:ext cx="7315200" cy="274320"/>
           </a:xfrm>
           <a:prstGeom prst="rect">
             <a:avLst/>
@@ -12150,29 +11748,14 @@
           <a:p>
             <a:pPr algn="l"/>
             <a:r>
-              <a:rPr sz="1000" b="0" i="0" dirty="0">
+              <a:rPr sz="1000" b="0" i="0">
                 <a:solidFill>
                   <a:srgbClr val="556070"/>
                 </a:solidFill>
                 <a:latin typeface="Calibri"/>
               </a:rPr>
-              <a:t>Online Shoppers Purchase-Intention Capstone  |  </a:t>
-            </a:r>
-            <a:r>
-              <a:rPr sz="1000" b="0" i="0" dirty="0" err="1">
-                <a:solidFill>
-                  <a:srgbClr val="556070"/>
-                </a:solidFill>
-                <a:latin typeface="Calibri"/>
-              </a:rPr>
-              <a:t>kNN</a:t>
-            </a:r>
-            <a:endParaRPr sz="1000" b="0" i="0" dirty="0">
-              <a:solidFill>
-                <a:srgbClr val="556070"/>
-              </a:solidFill>
-              <a:latin typeface="Calibri"/>
-            </a:endParaRPr>
+              <a:t>Online Shoppers Purchase-Intention Capstone  |  kNN from Scratch</a:t>
+            </a:r>
           </a:p>
         </p:txBody>
       </p:sp>
@@ -12206,7 +11789,7 @@
                 </a:solidFill>
                 <a:latin typeface="Calibri"/>
               </a:rPr>
-              <a:t>Slide 18</a:t>
+              <a:t>Slide 19</a:t>
             </a:r>
           </a:p>
         </p:txBody>
@@ -13376,7 +12959,7 @@
         <p:spPr>
           <a:xfrm>
             <a:off x="457200" y="6492240"/>
-            <a:ext cx="7315200" cy="246221"/>
+            <a:ext cx="7315200" cy="274320"/>
           </a:xfrm>
           <a:prstGeom prst="rect">
             <a:avLst/>
@@ -13391,29 +12974,14 @@
           <a:p>
             <a:pPr algn="l"/>
             <a:r>
-              <a:rPr sz="1000" b="0" i="0" dirty="0">
+              <a:rPr sz="1000" b="0" i="0">
                 <a:solidFill>
                   <a:srgbClr val="556070"/>
                 </a:solidFill>
                 <a:latin typeface="Calibri"/>
               </a:rPr>
-              <a:t>Online Shoppers Purchase-Intention Capstone  |  </a:t>
-            </a:r>
-            <a:r>
-              <a:rPr sz="1000" b="0" i="0" dirty="0" err="1">
-                <a:solidFill>
-                  <a:srgbClr val="556070"/>
-                </a:solidFill>
-                <a:latin typeface="Calibri"/>
-              </a:rPr>
-              <a:t>kNN</a:t>
-            </a:r>
-            <a:endParaRPr sz="1000" b="0" i="0" dirty="0">
-              <a:solidFill>
-                <a:srgbClr val="556070"/>
-              </a:solidFill>
-              <a:latin typeface="Calibri"/>
-            </a:endParaRPr>
+              <a:t>Online Shoppers Purchase-Intention Capstone  |  kNN from Scratch</a:t>
+            </a:r>
           </a:p>
         </p:txBody>
       </p:sp>
@@ -13447,7 +13015,7 @@
                 </a:solidFill>
                 <a:latin typeface="Calibri"/>
               </a:rPr>
-              <a:t>Slide 19</a:t>
+              <a:t>Slide 20</a:t>
             </a:r>
           </a:p>
         </p:txBody>
@@ -13644,7 +13212,7 @@
         <p:spPr>
           <a:xfrm>
             <a:off x="457200" y="1280160"/>
-            <a:ext cx="11247120" cy="323165"/>
+            <a:ext cx="11247120" cy="365760"/>
           </a:xfrm>
           <a:prstGeom prst="rect">
             <a:avLst/>
@@ -13659,22 +13227,13 @@
           <a:p>
             <a:pPr algn="l"/>
             <a:r>
-              <a:rPr lang="en-US" sz="1500" i="1" dirty="0">
+              <a:rPr sz="1500" b="0" i="1">
                 <a:solidFill>
                   <a:srgbClr val="556070"/>
                 </a:solidFill>
                 <a:latin typeface="Calibri"/>
               </a:rPr>
-              <a:t>F</a:t>
-            </a:r>
-            <a:r>
-              <a:rPr sz="1500" b="0" i="1" dirty="0">
-                <a:solidFill>
-                  <a:srgbClr val="556070"/>
-                </a:solidFill>
-                <a:latin typeface="Calibri"/>
-              </a:rPr>
-              <a:t>rom the question to the answer to the caveats.</a:t>
+              <a:t>Step-by-step problem solving — from the question to the answer to the caveats.</a:t>
             </a:r>
           </a:p>
         </p:txBody>
@@ -15073,7 +14632,7 @@
         <p:spPr>
           <a:xfrm>
             <a:off x="457200" y="6492240"/>
-            <a:ext cx="7315200" cy="246221"/>
+            <a:ext cx="7315200" cy="274320"/>
           </a:xfrm>
           <a:prstGeom prst="rect">
             <a:avLst/>
@@ -15088,29 +14647,14 @@
           <a:p>
             <a:pPr algn="l"/>
             <a:r>
-              <a:rPr sz="1000" b="0" i="0" dirty="0">
+              <a:rPr sz="1000" b="0" i="0">
                 <a:solidFill>
                   <a:srgbClr val="556070"/>
                 </a:solidFill>
                 <a:latin typeface="Calibri"/>
               </a:rPr>
-              <a:t>Online Shoppers Purchase-Intention Capstone  |  </a:t>
-            </a:r>
-            <a:r>
-              <a:rPr sz="1000" b="0" i="0" dirty="0" err="1">
-                <a:solidFill>
-                  <a:srgbClr val="556070"/>
-                </a:solidFill>
-                <a:latin typeface="Calibri"/>
-              </a:rPr>
-              <a:t>kNN</a:t>
-            </a:r>
-            <a:endParaRPr sz="1000" b="0" i="0" dirty="0">
-              <a:solidFill>
-                <a:srgbClr val="556070"/>
-              </a:solidFill>
-              <a:latin typeface="Calibri"/>
-            </a:endParaRPr>
+              <a:t>Online Shoppers Purchase-Intention Capstone  |  kNN from Scratch</a:t>
+            </a:r>
           </a:p>
         </p:txBody>
       </p:sp>
@@ -15444,7 +14988,7 @@
           <a:p>
             <a:pPr algn="ctr"/>
             <a:r>
-              <a:rPr sz="2000" b="1" i="0" dirty="0">
+              <a:rPr sz="2000" b="1" i="0">
                 <a:solidFill>
                   <a:srgbClr val="FFFFFF"/>
                 </a:solidFill>
@@ -15463,8 +15007,8 @@
         </p:nvSpPr>
         <p:spPr>
           <a:xfrm>
-            <a:off x="1417320" y="2413903"/>
-            <a:ext cx="10241280" cy="338554"/>
+            <a:off x="1417320" y="2194560"/>
+            <a:ext cx="10241280" cy="777240"/>
           </a:xfrm>
           <a:prstGeom prst="rect">
             <a:avLst/>
@@ -15479,49 +15023,13 @@
           <a:p>
             <a:pPr algn="l"/>
             <a:r>
-              <a:rPr sz="1600" b="0" i="0" dirty="0">
+              <a:rPr sz="1600" b="0" i="0">
                 <a:solidFill>
                   <a:srgbClr val="1A1A1A"/>
                 </a:solidFill>
                 <a:latin typeface="Calibri"/>
               </a:rPr>
-              <a:t>A </a:t>
-            </a:r>
-            <a:r>
-              <a:rPr sz="1600" b="0" i="0" dirty="0" err="1">
-                <a:solidFill>
-                  <a:srgbClr val="1A1A1A"/>
-                </a:solidFill>
-                <a:latin typeface="Calibri"/>
-              </a:rPr>
-              <a:t>kNN</a:t>
-            </a:r>
-            <a:r>
-              <a:rPr sz="1600" b="0" i="0" dirty="0">
-                <a:solidFill>
-                  <a:srgbClr val="1A1A1A"/>
-                </a:solidFill>
-                <a:latin typeface="Calibri"/>
-              </a:rPr>
-              <a:t> classifier</a:t>
-            </a:r>
-            <a:r>
-              <a:rPr lang="en-US" sz="1600" b="0" i="0" dirty="0">
-                <a:solidFill>
-                  <a:srgbClr val="1A1A1A"/>
-                </a:solidFill>
-                <a:latin typeface="Calibri"/>
-              </a:rPr>
-              <a:t> </a:t>
-            </a:r>
-            <a:r>
-              <a:rPr sz="1600" b="0" i="0" dirty="0">
-                <a:solidFill>
-                  <a:srgbClr val="1A1A1A"/>
-                </a:solidFill>
-                <a:latin typeface="Calibri"/>
-              </a:rPr>
-              <a:t>can learn real, transferable signal from web-session data.</a:t>
+              <a:t>A kNN classifier built from scratch can learn real, transferable signal from web-session data.</a:t>
             </a:r>
           </a:p>
         </p:txBody>
@@ -15629,7 +15137,7 @@
           <a:p>
             <a:pPr algn="l"/>
             <a:r>
-              <a:rPr sz="1600" b="0" i="0" dirty="0">
+              <a:rPr sz="1600" b="0" i="0">
                 <a:solidFill>
                   <a:srgbClr val="1A1A1A"/>
                 </a:solidFill>
@@ -15743,7 +15251,7 @@
           <a:p>
             <a:pPr algn="l"/>
             <a:r>
-              <a:rPr sz="1600" b="0" i="0" dirty="0">
+              <a:rPr sz="1600" b="0" i="0">
                 <a:solidFill>
                   <a:srgbClr val="1A1A1A"/>
                 </a:solidFill>
@@ -15857,7 +15365,7 @@
           <a:p>
             <a:pPr algn="l"/>
             <a:r>
-              <a:rPr sz="1600" b="0" i="0" dirty="0">
+              <a:rPr sz="1600" b="0" i="0">
                 <a:solidFill>
                   <a:srgbClr val="1A1A1A"/>
                 </a:solidFill>
@@ -15971,7 +15479,7 @@
           <a:p>
             <a:pPr algn="l"/>
             <a:r>
-              <a:rPr sz="1600" b="0" i="0" dirty="0">
+              <a:rPr sz="1600" b="0" i="0">
                 <a:solidFill>
                   <a:srgbClr val="1A1A1A"/>
                 </a:solidFill>
@@ -15991,7 +15499,7 @@
         <p:spPr>
           <a:xfrm>
             <a:off x="457200" y="6492240"/>
-            <a:ext cx="7315200" cy="246221"/>
+            <a:ext cx="7315200" cy="274320"/>
           </a:xfrm>
           <a:prstGeom prst="rect">
             <a:avLst/>
@@ -16006,29 +15514,14 @@
           <a:p>
             <a:pPr algn="l"/>
             <a:r>
-              <a:rPr sz="1000" b="0" i="0" dirty="0">
+              <a:rPr sz="1000" b="0" i="0">
                 <a:solidFill>
                   <a:srgbClr val="556070"/>
                 </a:solidFill>
                 <a:latin typeface="Calibri"/>
               </a:rPr>
-              <a:t>Online Shoppers Purchase-Intention Capstone  |  </a:t>
-            </a:r>
-            <a:r>
-              <a:rPr sz="1000" b="0" i="0" dirty="0" err="1">
-                <a:solidFill>
-                  <a:srgbClr val="556070"/>
-                </a:solidFill>
-                <a:latin typeface="Calibri"/>
-              </a:rPr>
-              <a:t>kNN</a:t>
-            </a:r>
-            <a:endParaRPr sz="1000" b="0" i="0" dirty="0">
-              <a:solidFill>
-                <a:srgbClr val="556070"/>
-              </a:solidFill>
-              <a:latin typeface="Calibri"/>
-            </a:endParaRPr>
+              <a:t>Online Shoppers Purchase-Intention Capstone  |  kNN from Scratch</a:t>
+            </a:r>
           </a:p>
         </p:txBody>
       </p:sp>
@@ -16062,7 +15555,7 @@
                 </a:solidFill>
                 <a:latin typeface="Calibri"/>
               </a:rPr>
-              <a:t>Slide 20</a:t>
+              <a:t>Slide 21</a:t>
             </a:r>
           </a:p>
         </p:txBody>
@@ -16260,7 +15753,7 @@
         <p:spPr>
           <a:xfrm>
             <a:off x="457200" y="4754880"/>
-            <a:ext cx="11247120" cy="369332"/>
+            <a:ext cx="11247120" cy="457200"/>
           </a:xfrm>
           <a:prstGeom prst="rect">
             <a:avLst/>
@@ -16275,29 +15768,49 @@
           <a:p>
             <a:pPr algn="ctr"/>
             <a:r>
-              <a:rPr sz="1800" b="0" i="0" dirty="0">
+              <a:rPr sz="1800" b="0" i="0">
                 <a:solidFill>
                   <a:srgbClr val="FFFFFF"/>
                 </a:solidFill>
                 <a:latin typeface="Calibri"/>
               </a:rPr>
-              <a:t>Predicting Online Shoppers’ Purchase Intention  •  </a:t>
-            </a:r>
-            <a:r>
-              <a:rPr sz="1800" b="0" i="0" dirty="0" err="1">
+              <a:t>Predicting Online Shoppers’ Purchase Intention  •  kNN from Scratch</a:t>
+            </a:r>
+          </a:p>
+        </p:txBody>
+      </p:sp>
+      <p:sp>
+        <p:nvSpPr>
+          <p:cNvPr id="7" name="TextBox 6"/>
+          <p:cNvSpPr txBox="1"/>
+          <p:nvPr/>
+        </p:nvSpPr>
+        <p:spPr>
+          <a:xfrm>
+            <a:off x="457200" y="5303520"/>
+            <a:ext cx="11247120" cy="457200"/>
+          </a:xfrm>
+          <a:prstGeom prst="rect">
+            <a:avLst/>
+          </a:prstGeom>
+          <a:noFill/>
+        </p:spPr>
+        <p:txBody>
+          <a:bodyPr wrap="square" anchor="t">
+            <a:spAutoFit/>
+          </a:bodyPr>
+          <a:lstStyle/>
+          <a:p>
+            <a:pPr algn="ctr"/>
+            <a:r>
+              <a:rPr sz="1400" b="0" i="1">
                 <a:solidFill>
                   <a:srgbClr val="FFFFFF"/>
                 </a:solidFill>
                 <a:latin typeface="Calibri"/>
               </a:rPr>
-              <a:t>kNN</a:t>
-            </a:r>
-            <a:endParaRPr sz="1800" b="0" i="0" dirty="0">
-              <a:solidFill>
-                <a:srgbClr val="FFFFFF"/>
-              </a:solidFill>
-              <a:latin typeface="Calibri"/>
-            </a:endParaRPr>
+              <a:t>Code, figures, and report bundled in the project folder.</a:t>
+            </a:r>
           </a:p>
         </p:txBody>
       </p:sp>
@@ -16508,7 +16021,7 @@
           <a:p>
             <a:pPr algn="l"/>
             <a:r>
-              <a:rPr sz="1500" b="0" i="1" dirty="0">
+              <a:rPr sz="1500" b="0" i="1">
                 <a:solidFill>
                   <a:srgbClr val="556070"/>
                 </a:solidFill>
@@ -16915,7 +16428,7 @@
         <p:spPr>
           <a:xfrm>
             <a:off x="457200" y="6492240"/>
-            <a:ext cx="7315200" cy="246221"/>
+            <a:ext cx="7315200" cy="274320"/>
           </a:xfrm>
           <a:prstGeom prst="rect">
             <a:avLst/>
@@ -16930,29 +16443,14 @@
           <a:p>
             <a:pPr algn="l"/>
             <a:r>
-              <a:rPr sz="1000" b="0" i="0" dirty="0">
+              <a:rPr sz="1000" b="0" i="0">
                 <a:solidFill>
                   <a:srgbClr val="556070"/>
                 </a:solidFill>
                 <a:latin typeface="Calibri"/>
               </a:rPr>
-              <a:t>Online Shoppers Purchase-Intention Capstone  |  </a:t>
-            </a:r>
-            <a:r>
-              <a:rPr sz="1000" b="0" i="0" dirty="0" err="1">
-                <a:solidFill>
-                  <a:srgbClr val="556070"/>
-                </a:solidFill>
-                <a:latin typeface="Calibri"/>
-              </a:rPr>
-              <a:t>kNN</a:t>
-            </a:r>
-            <a:endParaRPr sz="1000" b="0" i="0" dirty="0">
-              <a:solidFill>
-                <a:srgbClr val="556070"/>
-              </a:solidFill>
-              <a:latin typeface="Calibri"/>
-            </a:endParaRPr>
+              <a:t>Online Shoppers Purchase-Intention Capstone  |  kNN from Scratch</a:t>
+            </a:r>
           </a:p>
         </p:txBody>
       </p:sp>
@@ -18395,7 +17893,7 @@
         <p:spPr>
           <a:xfrm>
             <a:off x="457200" y="6492240"/>
-            <a:ext cx="7315200" cy="246221"/>
+            <a:ext cx="7315200" cy="274320"/>
           </a:xfrm>
           <a:prstGeom prst="rect">
             <a:avLst/>
@@ -18410,29 +17908,14 @@
           <a:p>
             <a:pPr algn="l"/>
             <a:r>
-              <a:rPr sz="1000" b="0" i="0" dirty="0">
+              <a:rPr sz="1000" b="0" i="0">
                 <a:solidFill>
                   <a:srgbClr val="556070"/>
                 </a:solidFill>
                 <a:latin typeface="Calibri"/>
               </a:rPr>
-              <a:t>Online Shoppers Purchase-Intention Capstone  |  </a:t>
-            </a:r>
-            <a:r>
-              <a:rPr sz="1000" b="0" i="0" dirty="0" err="1">
-                <a:solidFill>
-                  <a:srgbClr val="556070"/>
-                </a:solidFill>
-                <a:latin typeface="Calibri"/>
-              </a:rPr>
-              <a:t>kNN</a:t>
-            </a:r>
-            <a:endParaRPr sz="1000" b="0" i="0" dirty="0">
-              <a:solidFill>
-                <a:srgbClr val="556070"/>
-              </a:solidFill>
-              <a:latin typeface="Calibri"/>
-            </a:endParaRPr>
+              <a:t>Online Shoppers Purchase-Intention Capstone  |  kNN from Scratch</a:t>
+            </a:r>
           </a:p>
         </p:txBody>
       </p:sp>
@@ -18947,7 +18430,7 @@
         <p:spPr>
           <a:xfrm>
             <a:off x="457200" y="6492240"/>
-            <a:ext cx="7315200" cy="246221"/>
+            <a:ext cx="7315200" cy="274320"/>
           </a:xfrm>
           <a:prstGeom prst="rect">
             <a:avLst/>
@@ -18962,29 +18445,14 @@
           <a:p>
             <a:pPr algn="l"/>
             <a:r>
-              <a:rPr sz="1000" b="0" i="0" dirty="0">
+              <a:rPr sz="1000" b="0" i="0">
                 <a:solidFill>
                   <a:srgbClr val="556070"/>
                 </a:solidFill>
                 <a:latin typeface="Calibri"/>
               </a:rPr>
-              <a:t>Online Shoppers Purchase-Intention Capstone  |  </a:t>
-            </a:r>
-            <a:r>
-              <a:rPr sz="1000" b="0" i="0" dirty="0" err="1">
-                <a:solidFill>
-                  <a:srgbClr val="556070"/>
-                </a:solidFill>
-                <a:latin typeface="Calibri"/>
-              </a:rPr>
-              <a:t>kNN</a:t>
-            </a:r>
-            <a:endParaRPr sz="1000" b="0" i="0" dirty="0">
-              <a:solidFill>
-                <a:srgbClr val="556070"/>
-              </a:solidFill>
-              <a:latin typeface="Calibri"/>
-            </a:endParaRPr>
+              <a:t>Online Shoppers Purchase-Intention Capstone  |  kNN from Scratch</a:t>
+            </a:r>
           </a:p>
         </p:txBody>
       </p:sp>
@@ -19301,8 +18769,8 @@
         </p:blipFill>
         <p:spPr>
           <a:xfrm>
-            <a:off x="457200" y="1783080"/>
-            <a:ext cx="6736384" cy="4709160"/>
+            <a:off x="365760" y="1828800"/>
+            <a:ext cx="6858000" cy="6156000"/>
           </a:xfrm>
           <a:prstGeom prst="rect">
             <a:avLst/>
@@ -19557,7 +19025,7 @@
         <p:spPr>
           <a:xfrm>
             <a:off x="457200" y="6492240"/>
-            <a:ext cx="7315200" cy="246221"/>
+            <a:ext cx="7315200" cy="274320"/>
           </a:xfrm>
           <a:prstGeom prst="rect">
             <a:avLst/>
@@ -19572,29 +19040,14 @@
           <a:p>
             <a:pPr algn="l"/>
             <a:r>
-              <a:rPr sz="1000" b="0" i="0" dirty="0">
+              <a:rPr sz="1000" b="0" i="0">
                 <a:solidFill>
                   <a:srgbClr val="556070"/>
                 </a:solidFill>
                 <a:latin typeface="Calibri"/>
               </a:rPr>
-              <a:t>Online Shoppers Purchase-Intention Capstone  |  </a:t>
-            </a:r>
-            <a:r>
-              <a:rPr lang="en-US" sz="1000" b="0" i="0" dirty="0" err="1">
-                <a:solidFill>
-                  <a:srgbClr val="556070"/>
-                </a:solidFill>
-                <a:latin typeface="Calibri"/>
-              </a:rPr>
-              <a:t>kNN</a:t>
-            </a:r>
-            <a:endParaRPr sz="1000" b="0" i="0" dirty="0">
-              <a:solidFill>
-                <a:srgbClr val="556070"/>
-              </a:solidFill>
-              <a:latin typeface="Calibri"/>
-            </a:endParaRPr>
+              <a:t>Online Shoppers Purchase-Intention Capstone  |  kNN from Scratch</a:t>
+            </a:r>
           </a:p>
         </p:txBody>
       </p:sp>
@@ -20186,7 +19639,7 @@
         <p:spPr>
           <a:xfrm>
             <a:off x="457200" y="6492240"/>
-            <a:ext cx="7315200" cy="246221"/>
+            <a:ext cx="7315200" cy="274320"/>
           </a:xfrm>
           <a:prstGeom prst="rect">
             <a:avLst/>
@@ -20201,29 +19654,14 @@
           <a:p>
             <a:pPr algn="l"/>
             <a:r>
-              <a:rPr sz="1000" b="0" i="0" dirty="0">
+              <a:rPr sz="1000" b="0" i="0">
                 <a:solidFill>
                   <a:srgbClr val="556070"/>
                 </a:solidFill>
                 <a:latin typeface="Calibri"/>
               </a:rPr>
-              <a:t>Online Shoppers Purchase-Intention Capstone  |  </a:t>
-            </a:r>
-            <a:r>
-              <a:rPr sz="1000" b="0" i="0" dirty="0" err="1">
-                <a:solidFill>
-                  <a:srgbClr val="556070"/>
-                </a:solidFill>
-                <a:latin typeface="Calibri"/>
-              </a:rPr>
-              <a:t>kNN</a:t>
-            </a:r>
-            <a:endParaRPr sz="1000" b="0" i="0" dirty="0">
-              <a:solidFill>
-                <a:srgbClr val="556070"/>
-              </a:solidFill>
-              <a:latin typeface="Calibri"/>
-            </a:endParaRPr>
+              <a:t>Online Shoppers Purchase-Intention Capstone  |  kNN from Scratch</a:t>
+            </a:r>
           </a:p>
         </p:txBody>
       </p:sp>
@@ -20815,7 +20253,7 @@
         <p:spPr>
           <a:xfrm>
             <a:off x="457200" y="6492240"/>
-            <a:ext cx="7315200" cy="246221"/>
+            <a:ext cx="7315200" cy="274320"/>
           </a:xfrm>
           <a:prstGeom prst="rect">
             <a:avLst/>
@@ -20830,29 +20268,14 @@
           <a:p>
             <a:pPr algn="l"/>
             <a:r>
-              <a:rPr sz="1000" b="0" i="0" dirty="0">
+              <a:rPr sz="1000" b="0" i="0">
                 <a:solidFill>
                   <a:srgbClr val="556070"/>
                 </a:solidFill>
                 <a:latin typeface="Calibri"/>
               </a:rPr>
-              <a:t>Online Shoppers Purchase-Intention Capstone  |  </a:t>
-            </a:r>
-            <a:r>
-              <a:rPr sz="1000" b="0" i="0" dirty="0" err="1">
-                <a:solidFill>
-                  <a:srgbClr val="556070"/>
-                </a:solidFill>
-                <a:latin typeface="Calibri"/>
-              </a:rPr>
-              <a:t>kNN</a:t>
-            </a:r>
-            <a:endParaRPr sz="1000" b="0" i="0" dirty="0">
-              <a:solidFill>
-                <a:srgbClr val="556070"/>
-              </a:solidFill>
-              <a:latin typeface="Calibri"/>
-            </a:endParaRPr>
+              <a:t>Online Shoppers Purchase-Intention Capstone  |  kNN from Scratch</a:t>
+            </a:r>
           </a:p>
         </p:txBody>
       </p:sp>
@@ -21482,7 +20905,7 @@
         <p:spPr>
           <a:xfrm>
             <a:off x="457200" y="6492240"/>
-            <a:ext cx="7315200" cy="246221"/>
+            <a:ext cx="7315200" cy="274320"/>
           </a:xfrm>
           <a:prstGeom prst="rect">
             <a:avLst/>
@@ -21497,29 +20920,14 @@
           <a:p>
             <a:pPr algn="l"/>
             <a:r>
-              <a:rPr sz="1000" b="0" i="0" dirty="0">
+              <a:rPr sz="1000" b="0" i="0">
                 <a:solidFill>
                   <a:srgbClr val="556070"/>
                 </a:solidFill>
                 <a:latin typeface="Calibri"/>
               </a:rPr>
-              <a:t>Online Shoppers Purchase-Intention Capstone  |  </a:t>
-            </a:r>
-            <a:r>
-              <a:rPr sz="1000" b="0" i="0" dirty="0" err="1">
-                <a:solidFill>
-                  <a:srgbClr val="556070"/>
-                </a:solidFill>
-                <a:latin typeface="Calibri"/>
-              </a:rPr>
-              <a:t>kNN</a:t>
-            </a:r>
-            <a:endParaRPr sz="1000" b="0" i="0" dirty="0">
-              <a:solidFill>
-                <a:srgbClr val="556070"/>
-              </a:solidFill>
-              <a:latin typeface="Calibri"/>
-            </a:endParaRPr>
+              <a:t>Online Shoppers Purchase-Intention Capstone  |  kNN from Scratch</a:t>
+            </a:r>
           </a:p>
         </p:txBody>
       </p:sp>

</xml_diff>

<commit_message>
Add PDF and update PPTX capstone presentation
Add a PDF export of the capstone presentation for distribution and update the existing PowerPoint (.pptx) with recent edits. Provides both PDF and updated PPTX versions of the presentation.
</commit_message>
<xml_diff>
--- a/Capstone_Presentation.pptx
+++ b/Capstone_Presentation.pptx
@@ -322,7 +322,7 @@
           <a:p>
             <a:fld id="{5BCAD085-E8A6-8845-BD4E-CB4CCA059FC4}" type="datetimeFigureOut">
               <a:rPr lang="en-US" smtClean="0"/>
-              <a:t>5/22/2026</a:t>
+              <a:t>5/23/2026</a:t>
             </a:fld>
             <a:endParaRPr lang="en-US"/>
           </a:p>
@@ -490,7 +490,7 @@
           <a:p>
             <a:fld id="{5BCAD085-E8A6-8845-BD4E-CB4CCA059FC4}" type="datetimeFigureOut">
               <a:rPr lang="en-US" smtClean="0"/>
-              <a:t>5/22/2026</a:t>
+              <a:t>5/23/2026</a:t>
             </a:fld>
             <a:endParaRPr lang="en-US"/>
           </a:p>
@@ -668,7 +668,7 @@
           <a:p>
             <a:fld id="{5BCAD085-E8A6-8845-BD4E-CB4CCA059FC4}" type="datetimeFigureOut">
               <a:rPr lang="en-US" smtClean="0"/>
-              <a:t>5/22/2026</a:t>
+              <a:t>5/23/2026</a:t>
             </a:fld>
             <a:endParaRPr lang="en-US"/>
           </a:p>
@@ -836,7 +836,7 @@
           <a:p>
             <a:fld id="{5BCAD085-E8A6-8845-BD4E-CB4CCA059FC4}" type="datetimeFigureOut">
               <a:rPr lang="en-US" smtClean="0"/>
-              <a:t>5/22/2026</a:t>
+              <a:t>5/23/2026</a:t>
             </a:fld>
             <a:endParaRPr lang="en-US"/>
           </a:p>
@@ -1081,7 +1081,7 @@
           <a:p>
             <a:fld id="{5BCAD085-E8A6-8845-BD4E-CB4CCA059FC4}" type="datetimeFigureOut">
               <a:rPr lang="en-US" smtClean="0"/>
-              <a:t>5/22/2026</a:t>
+              <a:t>5/23/2026</a:t>
             </a:fld>
             <a:endParaRPr lang="en-US"/>
           </a:p>
@@ -1366,7 +1366,7 @@
           <a:p>
             <a:fld id="{5BCAD085-E8A6-8845-BD4E-CB4CCA059FC4}" type="datetimeFigureOut">
               <a:rPr lang="en-US" smtClean="0"/>
-              <a:t>5/22/2026</a:t>
+              <a:t>5/23/2026</a:t>
             </a:fld>
             <a:endParaRPr lang="en-US"/>
           </a:p>
@@ -1785,7 +1785,7 @@
           <a:p>
             <a:fld id="{5BCAD085-E8A6-8845-BD4E-CB4CCA059FC4}" type="datetimeFigureOut">
               <a:rPr lang="en-US" smtClean="0"/>
-              <a:t>5/22/2026</a:t>
+              <a:t>5/23/2026</a:t>
             </a:fld>
             <a:endParaRPr lang="en-US"/>
           </a:p>
@@ -1902,7 +1902,7 @@
           <a:p>
             <a:fld id="{5BCAD085-E8A6-8845-BD4E-CB4CCA059FC4}" type="datetimeFigureOut">
               <a:rPr lang="en-US" smtClean="0"/>
-              <a:t>5/22/2026</a:t>
+              <a:t>5/23/2026</a:t>
             </a:fld>
             <a:endParaRPr lang="en-US"/>
           </a:p>
@@ -1997,7 +1997,7 @@
           <a:p>
             <a:fld id="{5BCAD085-E8A6-8845-BD4E-CB4CCA059FC4}" type="datetimeFigureOut">
               <a:rPr lang="en-US" smtClean="0"/>
-              <a:t>5/22/2026</a:t>
+              <a:t>5/23/2026</a:t>
             </a:fld>
             <a:endParaRPr lang="en-US"/>
           </a:p>
@@ -2272,7 +2272,7 @@
           <a:p>
             <a:fld id="{5BCAD085-E8A6-8845-BD4E-CB4CCA059FC4}" type="datetimeFigureOut">
               <a:rPr lang="en-US" smtClean="0"/>
-              <a:t>5/22/2026</a:t>
+              <a:t>5/23/2026</a:t>
             </a:fld>
             <a:endParaRPr lang="en-US"/>
           </a:p>
@@ -2524,7 +2524,7 @@
           <a:p>
             <a:fld id="{5BCAD085-E8A6-8845-BD4E-CB4CCA059FC4}" type="datetimeFigureOut">
               <a:rPr lang="en-US" smtClean="0"/>
-              <a:t>5/22/2026</a:t>
+              <a:t>5/23/2026</a:t>
             </a:fld>
             <a:endParaRPr lang="en-US"/>
           </a:p>
@@ -2735,7 +2735,7 @@
           <a:p>
             <a:fld id="{5BCAD085-E8A6-8845-BD4E-CB4CCA059FC4}" type="datetimeFigureOut">
               <a:rPr lang="en-US" smtClean="0"/>
-              <a:t>5/22/2026</a:t>
+              <a:t>5/23/2026</a:t>
             </a:fld>
             <a:endParaRPr lang="en-US"/>
           </a:p>
@@ -5320,26 +5320,32 @@
                 </a:solidFill>
                 <a:latin typeface="Calibri"/>
               </a:rPr>
-              <a:t>The Pipeline We Built — Seven Scripts</a:t>
-            </a:r>
-            <a:r>
-              <a:rPr lang="en-US" sz="3000" b="1" dirty="0">
+              <a:t>The Pipeline We Built — </a:t>
+            </a:r>
+            <a:r>
+              <a:rPr sz="3000" b="1" i="0">
                 <a:solidFill>
                   <a:srgbClr val="1F3A5F"/>
                 </a:solidFill>
                 <a:latin typeface="Calibri"/>
               </a:rPr>
-              <a:t> </a:t>
-            </a:r>
-            <a:r>
-              <a:rPr sz="3000" b="1" i="0" dirty="0">
+              <a:t>Seven Script</a:t>
+            </a:r>
+            <a:r>
+              <a:rPr lang="en-US" sz="3000" b="1" i="0">
                 <a:solidFill>
                   <a:srgbClr val="1F3A5F"/>
                 </a:solidFill>
                 <a:latin typeface="Calibri"/>
               </a:rPr>
-              <a:t>Estimators</a:t>
-            </a:r>
+              <a:t>s</a:t>
+            </a:r>
+            <a:endParaRPr sz="3000" b="1" i="0" dirty="0">
+              <a:solidFill>
+                <a:srgbClr val="1F3A5F"/>
+              </a:solidFill>
+              <a:latin typeface="Calibri"/>
+            </a:endParaRPr>
           </a:p>
         </p:txBody>
       </p:sp>

</xml_diff>